<commit_message>
Lesson 1 Slides final
</commit_message>
<xml_diff>
--- a/Python/Lesson 01 - Python Basics/Lesson 1  - Intro to Python.pptx
+++ b/Python/Lesson 01 - Python Basics/Lesson 1  - Intro to Python.pptx
@@ -5,45 +5,46 @@
     <p:sldMasterId id="2147483673" r:id="rId1"/>
   </p:sldMasterIdLst>
   <p:notesMasterIdLst>
-    <p:notesMasterId r:id="rId38"/>
+    <p:notesMasterId r:id="rId39"/>
   </p:notesMasterIdLst>
   <p:sldIdLst>
     <p:sldId id="321" r:id="rId2"/>
     <p:sldId id="328" r:id="rId3"/>
     <p:sldId id="329" r:id="rId4"/>
     <p:sldId id="486" r:id="rId5"/>
-    <p:sldId id="304" r:id="rId6"/>
-    <p:sldId id="276" r:id="rId7"/>
-    <p:sldId id="305" r:id="rId8"/>
-    <p:sldId id="277" r:id="rId9"/>
-    <p:sldId id="300" r:id="rId10"/>
-    <p:sldId id="284" r:id="rId11"/>
-    <p:sldId id="324" r:id="rId12"/>
-    <p:sldId id="291" r:id="rId13"/>
-    <p:sldId id="323" r:id="rId14"/>
-    <p:sldId id="292" r:id="rId15"/>
-    <p:sldId id="285" r:id="rId16"/>
-    <p:sldId id="306" r:id="rId17"/>
-    <p:sldId id="301" r:id="rId18"/>
-    <p:sldId id="308" r:id="rId19"/>
-    <p:sldId id="325" r:id="rId20"/>
-    <p:sldId id="326" r:id="rId21"/>
-    <p:sldId id="287" r:id="rId22"/>
-    <p:sldId id="307" r:id="rId23"/>
-    <p:sldId id="293" r:id="rId24"/>
-    <p:sldId id="309" r:id="rId25"/>
-    <p:sldId id="289" r:id="rId26"/>
-    <p:sldId id="310" r:id="rId27"/>
-    <p:sldId id="311" r:id="rId28"/>
-    <p:sldId id="322" r:id="rId29"/>
-    <p:sldId id="330" r:id="rId30"/>
-    <p:sldId id="331" r:id="rId31"/>
-    <p:sldId id="332" r:id="rId32"/>
-    <p:sldId id="333" r:id="rId33"/>
-    <p:sldId id="334" r:id="rId34"/>
-    <p:sldId id="312" r:id="rId35"/>
-    <p:sldId id="327" r:id="rId36"/>
-    <p:sldId id="313" r:id="rId37"/>
+    <p:sldId id="487" r:id="rId6"/>
+    <p:sldId id="304" r:id="rId7"/>
+    <p:sldId id="276" r:id="rId8"/>
+    <p:sldId id="305" r:id="rId9"/>
+    <p:sldId id="277" r:id="rId10"/>
+    <p:sldId id="300" r:id="rId11"/>
+    <p:sldId id="284" r:id="rId12"/>
+    <p:sldId id="324" r:id="rId13"/>
+    <p:sldId id="291" r:id="rId14"/>
+    <p:sldId id="323" r:id="rId15"/>
+    <p:sldId id="292" r:id="rId16"/>
+    <p:sldId id="285" r:id="rId17"/>
+    <p:sldId id="306" r:id="rId18"/>
+    <p:sldId id="301" r:id="rId19"/>
+    <p:sldId id="308" r:id="rId20"/>
+    <p:sldId id="325" r:id="rId21"/>
+    <p:sldId id="326" r:id="rId22"/>
+    <p:sldId id="287" r:id="rId23"/>
+    <p:sldId id="307" r:id="rId24"/>
+    <p:sldId id="293" r:id="rId25"/>
+    <p:sldId id="309" r:id="rId26"/>
+    <p:sldId id="289" r:id="rId27"/>
+    <p:sldId id="310" r:id="rId28"/>
+    <p:sldId id="311" r:id="rId29"/>
+    <p:sldId id="322" r:id="rId30"/>
+    <p:sldId id="330" r:id="rId31"/>
+    <p:sldId id="331" r:id="rId32"/>
+    <p:sldId id="332" r:id="rId33"/>
+    <p:sldId id="333" r:id="rId34"/>
+    <p:sldId id="334" r:id="rId35"/>
+    <p:sldId id="312" r:id="rId36"/>
+    <p:sldId id="327" r:id="rId37"/>
+    <p:sldId id="313" r:id="rId38"/>
   </p:sldIdLst>
   <p:sldSz cx="9144000" cy="5143500" type="screen16x9"/>
   <p:notesSz cx="6858000" cy="9144000"/>
@@ -868,6 +869,133 @@
   <p:cSld>
     <p:spTree>
       <p:nvGrpSpPr>
+        <p:cNvPr id="1" name="Shape 351">
+          <a:extLst>
+            <a:ext uri="{FF2B5EF4-FFF2-40B4-BE49-F238E27FC236}">
+              <a16:creationId xmlns:a16="http://schemas.microsoft.com/office/drawing/2014/main" id="{7BB565DC-02B6-5292-0FFD-81AB874BFBD3}"/>
+            </a:ext>
+          </a:extLst>
+        </p:cNvPr>
+        <p:cNvGrpSpPr/>
+        <p:nvPr/>
+      </p:nvGrpSpPr>
+      <p:grpSpPr>
+        <a:xfrm>
+          <a:off x="0" y="0"/>
+          <a:ext cx="0" cy="0"/>
+          <a:chOff x="0" y="0"/>
+          <a:chExt cx="0" cy="0"/>
+        </a:xfrm>
+      </p:grpSpPr>
+      <p:sp>
+        <p:nvSpPr>
+          <p:cNvPr id="352" name="Google Shape;352;g364a009736c_2_267:notes">
+            <a:extLst>
+              <a:ext uri="{FF2B5EF4-FFF2-40B4-BE49-F238E27FC236}">
+                <a16:creationId xmlns:a16="http://schemas.microsoft.com/office/drawing/2014/main" id="{6C3BC44D-5ACD-7E94-567D-80A23BC7E725}"/>
+              </a:ext>
+            </a:extLst>
+          </p:cNvPr>
+          <p:cNvSpPr txBox="1">
+            <a:spLocks noGrp="1"/>
+          </p:cNvSpPr>
+          <p:nvPr>
+            <p:ph type="body" idx="1"/>
+          </p:nvPr>
+        </p:nvSpPr>
+        <p:spPr>
+          <a:xfrm>
+            <a:off x="685800" y="4343400"/>
+            <a:ext cx="5486400" cy="4114800"/>
+          </a:xfrm>
+          <a:prstGeom prst="rect">
+            <a:avLst/>
+          </a:prstGeom>
+        </p:spPr>
+        <p:txBody>
+          <a:bodyPr spcFirstLastPara="1" wrap="square" lIns="91425" tIns="91425" rIns="91425" bIns="91425" anchor="t" anchorCtr="0">
+            <a:noAutofit/>
+          </a:bodyPr>
+          <a:lstStyle/>
+          <a:p>
+            <a:pPr marL="0" lvl="0" indent="0" algn="l" rtl="0">
+              <a:spcBef>
+                <a:spcPts val="0"/>
+              </a:spcBef>
+              <a:spcAft>
+                <a:spcPts val="0"/>
+              </a:spcAft>
+              <a:buNone/>
+            </a:pPr>
+            <a:endParaRPr/>
+          </a:p>
+        </p:txBody>
+      </p:sp>
+      <p:sp>
+        <p:nvSpPr>
+          <p:cNvPr id="353" name="Google Shape;353;g364a009736c_2_267:notes">
+            <a:extLst>
+              <a:ext uri="{FF2B5EF4-FFF2-40B4-BE49-F238E27FC236}">
+                <a16:creationId xmlns:a16="http://schemas.microsoft.com/office/drawing/2014/main" id="{BA4593AD-D636-0929-A118-52287718C569}"/>
+              </a:ext>
+            </a:extLst>
+          </p:cNvPr>
+          <p:cNvSpPr>
+            <a:spLocks noGrp="1" noRot="1" noChangeAspect="1"/>
+          </p:cNvSpPr>
+          <p:nvPr>
+            <p:ph type="sldImg" idx="2"/>
+          </p:nvPr>
+        </p:nvSpPr>
+        <p:spPr>
+          <a:xfrm>
+            <a:off x="381000" y="685800"/>
+            <a:ext cx="6096000" cy="3429000"/>
+          </a:xfrm>
+          <a:custGeom>
+            <a:avLst/>
+            <a:gdLst/>
+            <a:ahLst/>
+            <a:cxnLst/>
+            <a:rect l="l" t="t" r="r" b="b"/>
+            <a:pathLst>
+              <a:path w="120000" h="120000" extrusionOk="0">
+                <a:moveTo>
+                  <a:pt x="0" y="0"/>
+                </a:moveTo>
+                <a:lnTo>
+                  <a:pt x="120000" y="0"/>
+                </a:lnTo>
+                <a:lnTo>
+                  <a:pt x="120000" y="120000"/>
+                </a:lnTo>
+                <a:lnTo>
+                  <a:pt x="0" y="120000"/>
+                </a:lnTo>
+                <a:close/>
+              </a:path>
+            </a:pathLst>
+          </a:custGeom>
+        </p:spPr>
+      </p:sp>
+    </p:spTree>
+    <p:extLst>
+      <p:ext uri="{BB962C8B-B14F-4D97-AF65-F5344CB8AC3E}">
+        <p14:creationId xmlns:p14="http://schemas.microsoft.com/office/powerpoint/2010/main" val="1546419728"/>
+      </p:ext>
+    </p:extLst>
+  </p:cSld>
+  <p:clrMapOvr>
+    <a:masterClrMapping/>
+  </p:clrMapOvr>
+</p:notes>
+</file>
+
+<file path=ppt/notesSlides/notesSlide11.xml><?xml version="1.0" encoding="utf-8"?>
+<p:notes xmlns:a="http://schemas.openxmlformats.org/drawingml/2006/main" xmlns:r="http://schemas.openxmlformats.org/officeDocument/2006/relationships" xmlns:p="http://schemas.openxmlformats.org/presentationml/2006/main" showMasterSp="0" showMasterPhAnim="0">
+  <p:cSld>
+    <p:spTree>
+      <p:nvGrpSpPr>
         <p:cNvPr id="1" name="Shape 351"/>
         <p:cNvGrpSpPr/>
         <p:nvPr/>
@@ -967,7 +1095,7 @@
 </p:notes>
 </file>
 
-<file path=ppt/notesSlides/notesSlide11.xml><?xml version="1.0" encoding="utf-8"?>
+<file path=ppt/notesSlides/notesSlide12.xml><?xml version="1.0" encoding="utf-8"?>
 <p:notes xmlns:a="http://schemas.openxmlformats.org/drawingml/2006/main" xmlns:r="http://schemas.openxmlformats.org/officeDocument/2006/relationships" xmlns:p="http://schemas.openxmlformats.org/presentationml/2006/main" showMasterSp="0" showMasterPhAnim="0">
   <p:cSld>
     <p:spTree>
@@ -1094,7 +1222,7 @@
 </p:notes>
 </file>
 
-<file path=ppt/notesSlides/notesSlide12.xml><?xml version="1.0" encoding="utf-8"?>
+<file path=ppt/notesSlides/notesSlide13.xml><?xml version="1.0" encoding="utf-8"?>
 <p:notes xmlns:a="http://schemas.openxmlformats.org/drawingml/2006/main" xmlns:r="http://schemas.openxmlformats.org/officeDocument/2006/relationships" xmlns:p="http://schemas.openxmlformats.org/presentationml/2006/main" showMasterSp="0" showMasterPhAnim="0">
   <p:cSld>
     <p:spTree>
@@ -1316,7 +1444,7 @@
                 <a:cs typeface="Arial"/>
                 <a:sym typeface="Arial"/>
               </a:rPr>
-              <a:t>14</a:t>
+              <a:t>15</a:t>
             </a:fld>
             <a:endParaRPr sz="1800">
               <a:solidFill>
@@ -1338,7 +1466,7 @@
 </p:notes>
 </file>
 
-<file path=ppt/notesSlides/notesSlide13.xml><?xml version="1.0" encoding="utf-8"?>
+<file path=ppt/notesSlides/notesSlide14.xml><?xml version="1.0" encoding="utf-8"?>
 <p:notes xmlns:a="http://schemas.openxmlformats.org/drawingml/2006/main" xmlns:r="http://schemas.openxmlformats.org/officeDocument/2006/relationships" xmlns:p="http://schemas.openxmlformats.org/presentationml/2006/main" showMasterSp="0" showMasterPhAnim="0">
   <p:cSld>
     <p:spTree>
@@ -1500,7 +1628,7 @@
                 <a:cs typeface="Arial"/>
                 <a:sym typeface="Arial"/>
               </a:rPr>
-              <a:t>15</a:t>
+              <a:t>16</a:t>
             </a:fld>
             <a:endParaRPr sz="1800">
               <a:solidFill>
@@ -1522,7 +1650,7 @@
 </p:notes>
 </file>
 
-<file path=ppt/notesSlides/notesSlide14.xml><?xml version="1.0" encoding="utf-8"?>
+<file path=ppt/notesSlides/notesSlide15.xml><?xml version="1.0" encoding="utf-8"?>
 <p:notes xmlns:a="http://schemas.openxmlformats.org/drawingml/2006/main" xmlns:r="http://schemas.openxmlformats.org/officeDocument/2006/relationships" xmlns:p="http://schemas.openxmlformats.org/presentationml/2006/main" showMasterSp="0" showMasterPhAnim="0">
   <p:cSld>
     <p:spTree>
@@ -1649,7 +1777,7 @@
 </p:notes>
 </file>
 
-<file path=ppt/notesSlides/notesSlide15.xml><?xml version="1.0" encoding="utf-8"?>
+<file path=ppt/notesSlides/notesSlide16.xml><?xml version="1.0" encoding="utf-8"?>
 <p:notes xmlns:a="http://schemas.openxmlformats.org/drawingml/2006/main" xmlns:r="http://schemas.openxmlformats.org/officeDocument/2006/relationships" xmlns:p="http://schemas.openxmlformats.org/presentationml/2006/main" showMasterSp="0" showMasterPhAnim="0">
   <p:cSld>
     <p:spTree>
@@ -1776,7 +1904,7 @@
 </p:notes>
 </file>
 
-<file path=ppt/notesSlides/notesSlide16.xml><?xml version="1.0" encoding="utf-8"?>
+<file path=ppt/notesSlides/notesSlide17.xml><?xml version="1.0" encoding="utf-8"?>
 <p:notes xmlns:a="http://schemas.openxmlformats.org/drawingml/2006/main" xmlns:r="http://schemas.openxmlformats.org/officeDocument/2006/relationships" xmlns:p="http://schemas.openxmlformats.org/presentationml/2006/main" showMasterSp="0" showMasterPhAnim="0">
   <p:cSld>
     <p:spTree>
@@ -1885,7 +2013,7 @@
 </p:notes>
 </file>
 
-<file path=ppt/notesSlides/notesSlide17.xml><?xml version="1.0" encoding="utf-8"?>
+<file path=ppt/notesSlides/notesSlide18.xml><?xml version="1.0" encoding="utf-8"?>
 <p:notes xmlns:a="http://schemas.openxmlformats.org/drawingml/2006/main" xmlns:r="http://schemas.openxmlformats.org/officeDocument/2006/relationships" xmlns:p="http://schemas.openxmlformats.org/presentationml/2006/main" showMasterSp="0" showMasterPhAnim="0">
   <p:cSld>
     <p:spTree>
@@ -2071,7 +2199,7 @@
                 <a:cs typeface="Arial"/>
                 <a:sym typeface="Arial"/>
               </a:rPr>
-              <a:t>22</a:t>
+              <a:t>23</a:t>
             </a:fld>
             <a:endParaRPr sz="1800">
               <a:solidFill>
@@ -2098,7 +2226,7 @@
 </p:notes>
 </file>
 
-<file path=ppt/notesSlides/notesSlide18.xml><?xml version="1.0" encoding="utf-8"?>
+<file path=ppt/notesSlides/notesSlide19.xml><?xml version="1.0" encoding="utf-8"?>
 <p:notes xmlns:a="http://schemas.openxmlformats.org/drawingml/2006/main" xmlns:r="http://schemas.openxmlformats.org/officeDocument/2006/relationships" xmlns:p="http://schemas.openxmlformats.org/presentationml/2006/main" showMasterSp="0" showMasterPhAnim="0">
   <p:cSld>
     <p:spTree>
@@ -2260,7 +2388,7 @@
                 <a:cs typeface="Arial"/>
                 <a:sym typeface="Arial"/>
               </a:rPr>
-              <a:t>23</a:t>
+              <a:t>24</a:t>
             </a:fld>
             <a:endParaRPr sz="1800">
               <a:solidFill>
@@ -2282,7 +2410,134 @@
 </p:notes>
 </file>
 
-<file path=ppt/notesSlides/notesSlide19.xml><?xml version="1.0" encoding="utf-8"?>
+<file path=ppt/notesSlides/notesSlide2.xml><?xml version="1.0" encoding="utf-8"?>
+<p:notes xmlns:a="http://schemas.openxmlformats.org/drawingml/2006/main" xmlns:r="http://schemas.openxmlformats.org/officeDocument/2006/relationships" xmlns:p="http://schemas.openxmlformats.org/presentationml/2006/main" showMasterSp="0" showMasterPhAnim="0">
+  <p:cSld>
+    <p:spTree>
+      <p:nvGrpSpPr>
+        <p:cNvPr id="1" name="Shape 256">
+          <a:extLst>
+            <a:ext uri="{FF2B5EF4-FFF2-40B4-BE49-F238E27FC236}">
+              <a16:creationId xmlns:a16="http://schemas.microsoft.com/office/drawing/2014/main" id="{F9A78601-1317-308F-EBF0-CF3337B3E8DE}"/>
+            </a:ext>
+          </a:extLst>
+        </p:cNvPr>
+        <p:cNvGrpSpPr/>
+        <p:nvPr/>
+      </p:nvGrpSpPr>
+      <p:grpSpPr>
+        <a:xfrm>
+          <a:off x="0" y="0"/>
+          <a:ext cx="0" cy="0"/>
+          <a:chOff x="0" y="0"/>
+          <a:chExt cx="0" cy="0"/>
+        </a:xfrm>
+      </p:grpSpPr>
+      <p:sp>
+        <p:nvSpPr>
+          <p:cNvPr id="257" name="Google Shape;257;g364a009736c_2_187:notes">
+            <a:extLst>
+              <a:ext uri="{FF2B5EF4-FFF2-40B4-BE49-F238E27FC236}">
+                <a16:creationId xmlns:a16="http://schemas.microsoft.com/office/drawing/2014/main" id="{B0BF3B59-447E-0894-9988-62D62BC80EA8}"/>
+              </a:ext>
+            </a:extLst>
+          </p:cNvPr>
+          <p:cNvSpPr txBox="1">
+            <a:spLocks noGrp="1"/>
+          </p:cNvSpPr>
+          <p:nvPr>
+            <p:ph type="body" idx="1"/>
+          </p:nvPr>
+        </p:nvSpPr>
+        <p:spPr>
+          <a:xfrm>
+            <a:off x="685800" y="4343400"/>
+            <a:ext cx="5486400" cy="4114800"/>
+          </a:xfrm>
+          <a:prstGeom prst="rect">
+            <a:avLst/>
+          </a:prstGeom>
+        </p:spPr>
+        <p:txBody>
+          <a:bodyPr spcFirstLastPara="1" wrap="square" lIns="91425" tIns="91425" rIns="91425" bIns="91425" anchor="t" anchorCtr="0">
+            <a:noAutofit/>
+          </a:bodyPr>
+          <a:lstStyle/>
+          <a:p>
+            <a:pPr marL="0" lvl="0" indent="0" algn="l" rtl="0">
+              <a:spcBef>
+                <a:spcPts val="0"/>
+              </a:spcBef>
+              <a:spcAft>
+                <a:spcPts val="0"/>
+              </a:spcAft>
+              <a:buNone/>
+            </a:pPr>
+            <a:endParaRPr/>
+          </a:p>
+        </p:txBody>
+      </p:sp>
+      <p:sp>
+        <p:nvSpPr>
+          <p:cNvPr id="258" name="Google Shape;258;g364a009736c_2_187:notes">
+            <a:extLst>
+              <a:ext uri="{FF2B5EF4-FFF2-40B4-BE49-F238E27FC236}">
+                <a16:creationId xmlns:a16="http://schemas.microsoft.com/office/drawing/2014/main" id="{A5F036A4-B5E8-319A-3C65-C697263855C0}"/>
+              </a:ext>
+            </a:extLst>
+          </p:cNvPr>
+          <p:cNvSpPr>
+            <a:spLocks noGrp="1" noRot="1" noChangeAspect="1"/>
+          </p:cNvSpPr>
+          <p:nvPr>
+            <p:ph type="sldImg" idx="2"/>
+          </p:nvPr>
+        </p:nvSpPr>
+        <p:spPr>
+          <a:xfrm>
+            <a:off x="381000" y="685800"/>
+            <a:ext cx="6096000" cy="3429000"/>
+          </a:xfrm>
+          <a:custGeom>
+            <a:avLst/>
+            <a:gdLst/>
+            <a:ahLst/>
+            <a:cxnLst/>
+            <a:rect l="l" t="t" r="r" b="b"/>
+            <a:pathLst>
+              <a:path w="120000" h="120000" extrusionOk="0">
+                <a:moveTo>
+                  <a:pt x="0" y="0"/>
+                </a:moveTo>
+                <a:lnTo>
+                  <a:pt x="120000" y="0"/>
+                </a:lnTo>
+                <a:lnTo>
+                  <a:pt x="120000" y="120000"/>
+                </a:lnTo>
+                <a:lnTo>
+                  <a:pt x="0" y="120000"/>
+                </a:lnTo>
+                <a:close/>
+              </a:path>
+            </a:pathLst>
+          </a:custGeom>
+        </p:spPr>
+      </p:sp>
+    </p:spTree>
+    <p:extLst>
+      <p:ext uri="{BB962C8B-B14F-4D97-AF65-F5344CB8AC3E}">
+        <p14:creationId xmlns:p14="http://schemas.microsoft.com/office/powerpoint/2010/main" val="225783322"/>
+      </p:ext>
+    </p:extLst>
+  </p:cSld>
+  <p:clrMapOvr>
+    <a:masterClrMapping/>
+  </p:clrMapOvr>
+</p:notes>
+</file>
+
+<file path=ppt/notesSlides/notesSlide20.xml><?xml version="1.0" encoding="utf-8"?>
 <p:notes xmlns:a="http://schemas.openxmlformats.org/drawingml/2006/main" xmlns:r="http://schemas.openxmlformats.org/officeDocument/2006/relationships" xmlns:p="http://schemas.openxmlformats.org/presentationml/2006/main" showMasterSp="0" showMasterPhAnim="0">
   <p:cSld>
     <p:spTree>
@@ -2468,7 +2723,7 @@
                 <a:cs typeface="Arial"/>
                 <a:sym typeface="Arial"/>
               </a:rPr>
-              <a:t>24</a:t>
+              <a:t>25</a:t>
             </a:fld>
             <a:endParaRPr sz="1800">
               <a:solidFill>
@@ -2495,134 +2750,7 @@
 </p:notes>
 </file>
 
-<file path=ppt/notesSlides/notesSlide2.xml><?xml version="1.0" encoding="utf-8"?>
-<p:notes xmlns:a="http://schemas.openxmlformats.org/drawingml/2006/main" xmlns:r="http://schemas.openxmlformats.org/officeDocument/2006/relationships" xmlns:p="http://schemas.openxmlformats.org/presentationml/2006/main" showMasterSp="0" showMasterPhAnim="0">
-  <p:cSld>
-    <p:spTree>
-      <p:nvGrpSpPr>
-        <p:cNvPr id="1" name="Shape 256">
-          <a:extLst>
-            <a:ext uri="{FF2B5EF4-FFF2-40B4-BE49-F238E27FC236}">
-              <a16:creationId xmlns:a16="http://schemas.microsoft.com/office/drawing/2014/main" id="{F9A78601-1317-308F-EBF0-CF3337B3E8DE}"/>
-            </a:ext>
-          </a:extLst>
-        </p:cNvPr>
-        <p:cNvGrpSpPr/>
-        <p:nvPr/>
-      </p:nvGrpSpPr>
-      <p:grpSpPr>
-        <a:xfrm>
-          <a:off x="0" y="0"/>
-          <a:ext cx="0" cy="0"/>
-          <a:chOff x="0" y="0"/>
-          <a:chExt cx="0" cy="0"/>
-        </a:xfrm>
-      </p:grpSpPr>
-      <p:sp>
-        <p:nvSpPr>
-          <p:cNvPr id="257" name="Google Shape;257;g364a009736c_2_187:notes">
-            <a:extLst>
-              <a:ext uri="{FF2B5EF4-FFF2-40B4-BE49-F238E27FC236}">
-                <a16:creationId xmlns:a16="http://schemas.microsoft.com/office/drawing/2014/main" id="{B0BF3B59-447E-0894-9988-62D62BC80EA8}"/>
-              </a:ext>
-            </a:extLst>
-          </p:cNvPr>
-          <p:cNvSpPr txBox="1">
-            <a:spLocks noGrp="1"/>
-          </p:cNvSpPr>
-          <p:nvPr>
-            <p:ph type="body" idx="1"/>
-          </p:nvPr>
-        </p:nvSpPr>
-        <p:spPr>
-          <a:xfrm>
-            <a:off x="685800" y="4343400"/>
-            <a:ext cx="5486400" cy="4114800"/>
-          </a:xfrm>
-          <a:prstGeom prst="rect">
-            <a:avLst/>
-          </a:prstGeom>
-        </p:spPr>
-        <p:txBody>
-          <a:bodyPr spcFirstLastPara="1" wrap="square" lIns="91425" tIns="91425" rIns="91425" bIns="91425" anchor="t" anchorCtr="0">
-            <a:noAutofit/>
-          </a:bodyPr>
-          <a:lstStyle/>
-          <a:p>
-            <a:pPr marL="0" lvl="0" indent="0" algn="l" rtl="0">
-              <a:spcBef>
-                <a:spcPts val="0"/>
-              </a:spcBef>
-              <a:spcAft>
-                <a:spcPts val="0"/>
-              </a:spcAft>
-              <a:buNone/>
-            </a:pPr>
-            <a:endParaRPr/>
-          </a:p>
-        </p:txBody>
-      </p:sp>
-      <p:sp>
-        <p:nvSpPr>
-          <p:cNvPr id="258" name="Google Shape;258;g364a009736c_2_187:notes">
-            <a:extLst>
-              <a:ext uri="{FF2B5EF4-FFF2-40B4-BE49-F238E27FC236}">
-                <a16:creationId xmlns:a16="http://schemas.microsoft.com/office/drawing/2014/main" id="{A5F036A4-B5E8-319A-3C65-C697263855C0}"/>
-              </a:ext>
-            </a:extLst>
-          </p:cNvPr>
-          <p:cNvSpPr>
-            <a:spLocks noGrp="1" noRot="1" noChangeAspect="1"/>
-          </p:cNvSpPr>
-          <p:nvPr>
-            <p:ph type="sldImg" idx="2"/>
-          </p:nvPr>
-        </p:nvSpPr>
-        <p:spPr>
-          <a:xfrm>
-            <a:off x="381000" y="685800"/>
-            <a:ext cx="6096000" cy="3429000"/>
-          </a:xfrm>
-          <a:custGeom>
-            <a:avLst/>
-            <a:gdLst/>
-            <a:ahLst/>
-            <a:cxnLst/>
-            <a:rect l="l" t="t" r="r" b="b"/>
-            <a:pathLst>
-              <a:path w="120000" h="120000" extrusionOk="0">
-                <a:moveTo>
-                  <a:pt x="0" y="0"/>
-                </a:moveTo>
-                <a:lnTo>
-                  <a:pt x="120000" y="0"/>
-                </a:lnTo>
-                <a:lnTo>
-                  <a:pt x="120000" y="120000"/>
-                </a:lnTo>
-                <a:lnTo>
-                  <a:pt x="0" y="120000"/>
-                </a:lnTo>
-                <a:close/>
-              </a:path>
-            </a:pathLst>
-          </a:custGeom>
-        </p:spPr>
-      </p:sp>
-    </p:spTree>
-    <p:extLst>
-      <p:ext uri="{BB962C8B-B14F-4D97-AF65-F5344CB8AC3E}">
-        <p14:creationId xmlns:p14="http://schemas.microsoft.com/office/powerpoint/2010/main" val="225783322"/>
-      </p:ext>
-    </p:extLst>
-  </p:cSld>
-  <p:clrMapOvr>
-    <a:masterClrMapping/>
-  </p:clrMapOvr>
-</p:notes>
-</file>
-
-<file path=ppt/notesSlides/notesSlide20.xml><?xml version="1.0" encoding="utf-8"?>
+<file path=ppt/notesSlides/notesSlide21.xml><?xml version="1.0" encoding="utf-8"?>
 <p:notes xmlns:a="http://schemas.openxmlformats.org/drawingml/2006/main" xmlns:r="http://schemas.openxmlformats.org/officeDocument/2006/relationships" xmlns:p="http://schemas.openxmlformats.org/presentationml/2006/main" showMasterSp="0" showMasterPhAnim="0">
   <p:cSld>
     <p:spTree>
@@ -2726,7 +2854,7 @@
 </p:notes>
 </file>
 
-<file path=ppt/notesSlides/notesSlide21.xml><?xml version="1.0" encoding="utf-8"?>
+<file path=ppt/notesSlides/notesSlide22.xml><?xml version="1.0" encoding="utf-8"?>
 <p:notes xmlns:a="http://schemas.openxmlformats.org/drawingml/2006/main" xmlns:r="http://schemas.openxmlformats.org/officeDocument/2006/relationships" xmlns:p="http://schemas.openxmlformats.org/presentationml/2006/main" showMasterSp="0" showMasterPhAnim="0">
   <p:cSld>
     <p:spTree>
@@ -2853,7 +2981,7 @@
 </p:notes>
 </file>
 
-<file path=ppt/notesSlides/notesSlide22.xml><?xml version="1.0" encoding="utf-8"?>
+<file path=ppt/notesSlides/notesSlide23.xml><?xml version="1.0" encoding="utf-8"?>
 <p:notes xmlns:a="http://schemas.openxmlformats.org/drawingml/2006/main" xmlns:r="http://schemas.openxmlformats.org/officeDocument/2006/relationships" xmlns:p="http://schemas.openxmlformats.org/presentationml/2006/main" showMasterSp="0" showMasterPhAnim="0">
   <p:cSld>
     <p:spTree>
@@ -3039,7 +3167,7 @@
                 <a:cs typeface="Arial"/>
                 <a:sym typeface="Arial"/>
               </a:rPr>
-              <a:t>34</a:t>
+              <a:t>35</a:t>
             </a:fld>
             <a:endParaRPr sz="1800">
               <a:solidFill>
@@ -3066,7 +3194,7 @@
 </p:notes>
 </file>
 
-<file path=ppt/notesSlides/notesSlide23.xml><?xml version="1.0" encoding="utf-8"?>
+<file path=ppt/notesSlides/notesSlide24.xml><?xml version="1.0" encoding="utf-8"?>
 <p:notes xmlns:a="http://schemas.openxmlformats.org/drawingml/2006/main" xmlns:r="http://schemas.openxmlformats.org/officeDocument/2006/relationships" xmlns:p="http://schemas.openxmlformats.org/presentationml/2006/main" showMasterSp="0" showMasterPhAnim="0">
   <p:cSld>
     <p:spTree>
@@ -3252,7 +3380,7 @@
                 <a:cs typeface="Arial"/>
                 <a:sym typeface="Arial"/>
               </a:rPr>
-              <a:t>35</a:t>
+              <a:t>36</a:t>
             </a:fld>
             <a:endParaRPr sz="1800">
               <a:solidFill>
@@ -3393,6 +3521,119 @@
 </file>
 
 <file path=ppt/notesSlides/notesSlide4.xml><?xml version="1.0" encoding="utf-8"?>
+<p:notes xmlns:a="http://schemas.openxmlformats.org/drawingml/2006/main" xmlns:r="http://schemas.openxmlformats.org/officeDocument/2006/relationships" xmlns:p="http://schemas.openxmlformats.org/presentationml/2006/main">
+  <p:cSld>
+    <p:spTree>
+      <p:nvGrpSpPr>
+        <p:cNvPr id="1" name="">
+          <a:extLst>
+            <a:ext uri="{FF2B5EF4-FFF2-40B4-BE49-F238E27FC236}">
+              <a16:creationId xmlns:a16="http://schemas.microsoft.com/office/drawing/2014/main" id="{E5EAEA0C-34BF-4336-1F66-591CF4EF4C3C}"/>
+            </a:ext>
+          </a:extLst>
+        </p:cNvPr>
+        <p:cNvGrpSpPr/>
+        <p:nvPr/>
+      </p:nvGrpSpPr>
+      <p:grpSpPr>
+        <a:xfrm>
+          <a:off x="0" y="0"/>
+          <a:ext cx="0" cy="0"/>
+          <a:chOff x="0" y="0"/>
+          <a:chExt cx="0" cy="0"/>
+        </a:xfrm>
+      </p:grpSpPr>
+      <p:sp>
+        <p:nvSpPr>
+          <p:cNvPr id="2" name="Slide Image Placeholder 1">
+            <a:extLst>
+              <a:ext uri="{FF2B5EF4-FFF2-40B4-BE49-F238E27FC236}">
+                <a16:creationId xmlns:a16="http://schemas.microsoft.com/office/drawing/2014/main" id="{EEAF434B-A113-1903-CFCF-445ED7284097}"/>
+              </a:ext>
+            </a:extLst>
+          </p:cNvPr>
+          <p:cNvSpPr>
+            <a:spLocks noGrp="1" noRot="1" noChangeAspect="1"/>
+          </p:cNvSpPr>
+          <p:nvPr>
+            <p:ph type="sldImg"/>
+          </p:nvPr>
+        </p:nvSpPr>
+        <p:spPr>
+          <a:xfrm>
+            <a:off x="381000" y="685800"/>
+            <a:ext cx="6096000" cy="3429000"/>
+          </a:xfrm>
+        </p:spPr>
+      </p:sp>
+      <p:sp>
+        <p:nvSpPr>
+          <p:cNvPr id="3" name="Notes Placeholder 2">
+            <a:extLst>
+              <a:ext uri="{FF2B5EF4-FFF2-40B4-BE49-F238E27FC236}">
+                <a16:creationId xmlns:a16="http://schemas.microsoft.com/office/drawing/2014/main" id="{0AD8DFAF-F2F9-6843-2171-A7E2918B1777}"/>
+              </a:ext>
+            </a:extLst>
+          </p:cNvPr>
+          <p:cNvSpPr>
+            <a:spLocks noGrp="1"/>
+          </p:cNvSpPr>
+          <p:nvPr>
+            <p:ph type="body" idx="1"/>
+          </p:nvPr>
+        </p:nvSpPr>
+        <p:spPr/>
+        <p:txBody>
+          <a:bodyPr/>
+          <a:lstStyle/>
+          <a:p>
+            <a:endParaRPr lang="en-US" dirty="0"/>
+          </a:p>
+        </p:txBody>
+      </p:sp>
+      <p:sp>
+        <p:nvSpPr>
+          <p:cNvPr id="4" name="Slide Number Placeholder 3">
+            <a:extLst>
+              <a:ext uri="{FF2B5EF4-FFF2-40B4-BE49-F238E27FC236}">
+                <a16:creationId xmlns:a16="http://schemas.microsoft.com/office/drawing/2014/main" id="{7ED75745-85F8-146B-5D5D-E31E1E201440}"/>
+              </a:ext>
+            </a:extLst>
+          </p:cNvPr>
+          <p:cNvSpPr>
+            <a:spLocks noGrp="1"/>
+          </p:cNvSpPr>
+          <p:nvPr>
+            <p:ph type="sldNum" sz="quarter" idx="5"/>
+          </p:nvPr>
+        </p:nvSpPr>
+        <p:spPr/>
+        <p:txBody>
+          <a:bodyPr/>
+          <a:lstStyle/>
+          <a:p>
+            <a:fld id="{292570D5-C374-43AE-876B-55C2A221664E}" type="slidenum">
+              <a:rPr lang="en-US" smtClean="0"/>
+              <a:t>5</a:t>
+            </a:fld>
+            <a:endParaRPr lang="en-US"/>
+          </a:p>
+        </p:txBody>
+      </p:sp>
+    </p:spTree>
+    <p:extLst>
+      <p:ext uri="{BB962C8B-B14F-4D97-AF65-F5344CB8AC3E}">
+        <p14:creationId xmlns:p14="http://schemas.microsoft.com/office/powerpoint/2010/main" val="4160803338"/>
+      </p:ext>
+    </p:extLst>
+  </p:cSld>
+  <p:clrMapOvr>
+    <a:masterClrMapping/>
+  </p:clrMapOvr>
+</p:notes>
+</file>
+
+<file path=ppt/notesSlides/notesSlide5.xml><?xml version="1.0" encoding="utf-8"?>
 <p:notes xmlns:a="http://schemas.openxmlformats.org/drawingml/2006/main" xmlns:r="http://schemas.openxmlformats.org/officeDocument/2006/relationships" xmlns:p="http://schemas.openxmlformats.org/presentationml/2006/main" showMasterSp="0" showMasterPhAnim="0">
   <p:cSld>
     <p:spTree>
@@ -3519,7 +3760,7 @@
 </p:notes>
 </file>
 
-<file path=ppt/notesSlides/notesSlide5.xml><?xml version="1.0" encoding="utf-8"?>
+<file path=ppt/notesSlides/notesSlide6.xml><?xml version="1.0" encoding="utf-8"?>
 <p:notes xmlns:a="http://schemas.openxmlformats.org/drawingml/2006/main" xmlns:r="http://schemas.openxmlformats.org/officeDocument/2006/relationships" xmlns:p="http://schemas.openxmlformats.org/presentationml/2006/main" showMasterSp="0" showMasterPhAnim="0">
   <p:cSld>
     <p:spTree>
@@ -3623,7 +3864,7 @@
 </p:notes>
 </file>
 
-<file path=ppt/notesSlides/notesSlide6.xml><?xml version="1.0" encoding="utf-8"?>
+<file path=ppt/notesSlides/notesSlide7.xml><?xml version="1.0" encoding="utf-8"?>
 <p:notes xmlns:a="http://schemas.openxmlformats.org/drawingml/2006/main" xmlns:r="http://schemas.openxmlformats.org/officeDocument/2006/relationships" xmlns:p="http://schemas.openxmlformats.org/presentationml/2006/main" showMasterSp="0" showMasterPhAnim="0">
   <p:cSld>
     <p:spTree>
@@ -3727,7 +3968,7 @@
 </p:notes>
 </file>
 
-<file path=ppt/notesSlides/notesSlide7.xml><?xml version="1.0" encoding="utf-8"?>
+<file path=ppt/notesSlides/notesSlide8.xml><?xml version="1.0" encoding="utf-8"?>
 <p:notes xmlns:a="http://schemas.openxmlformats.org/drawingml/2006/main" xmlns:r="http://schemas.openxmlformats.org/officeDocument/2006/relationships" xmlns:p="http://schemas.openxmlformats.org/presentationml/2006/main">
   <p:cSld>
     <p:spTree>
@@ -3805,7 +4046,7 @@
 </p:notes>
 </file>
 
-<file path=ppt/notesSlides/notesSlide8.xml><?xml version="1.0" encoding="utf-8"?>
+<file path=ppt/notesSlides/notesSlide9.xml><?xml version="1.0" encoding="utf-8"?>
 <p:notes xmlns:a="http://schemas.openxmlformats.org/drawingml/2006/main" xmlns:r="http://schemas.openxmlformats.org/officeDocument/2006/relationships" xmlns:p="http://schemas.openxmlformats.org/presentationml/2006/main" showMasterSp="0" showMasterPhAnim="0">
   <p:cSld>
     <p:spTree>
@@ -4147,7 +4388,7 @@
                 <a:cs typeface="Arial"/>
                 <a:sym typeface="Arial"/>
               </a:rPr>
-              <a:t>10</a:t>
+              <a:t>11</a:t>
             </a:fld>
             <a:endParaRPr sz="1800">
               <a:solidFill>
@@ -4162,133 +4403,6 @@
         </p:txBody>
       </p:sp>
     </p:spTree>
-  </p:cSld>
-  <p:clrMapOvr>
-    <a:masterClrMapping/>
-  </p:clrMapOvr>
-</p:notes>
-</file>
-
-<file path=ppt/notesSlides/notesSlide9.xml><?xml version="1.0" encoding="utf-8"?>
-<p:notes xmlns:a="http://schemas.openxmlformats.org/drawingml/2006/main" xmlns:r="http://schemas.openxmlformats.org/officeDocument/2006/relationships" xmlns:p="http://schemas.openxmlformats.org/presentationml/2006/main" showMasterSp="0" showMasterPhAnim="0">
-  <p:cSld>
-    <p:spTree>
-      <p:nvGrpSpPr>
-        <p:cNvPr id="1" name="Shape 351">
-          <a:extLst>
-            <a:ext uri="{FF2B5EF4-FFF2-40B4-BE49-F238E27FC236}">
-              <a16:creationId xmlns:a16="http://schemas.microsoft.com/office/drawing/2014/main" id="{7BB565DC-02B6-5292-0FFD-81AB874BFBD3}"/>
-            </a:ext>
-          </a:extLst>
-        </p:cNvPr>
-        <p:cNvGrpSpPr/>
-        <p:nvPr/>
-      </p:nvGrpSpPr>
-      <p:grpSpPr>
-        <a:xfrm>
-          <a:off x="0" y="0"/>
-          <a:ext cx="0" cy="0"/>
-          <a:chOff x="0" y="0"/>
-          <a:chExt cx="0" cy="0"/>
-        </a:xfrm>
-      </p:grpSpPr>
-      <p:sp>
-        <p:nvSpPr>
-          <p:cNvPr id="352" name="Google Shape;352;g364a009736c_2_267:notes">
-            <a:extLst>
-              <a:ext uri="{FF2B5EF4-FFF2-40B4-BE49-F238E27FC236}">
-                <a16:creationId xmlns:a16="http://schemas.microsoft.com/office/drawing/2014/main" id="{6C3BC44D-5ACD-7E94-567D-80A23BC7E725}"/>
-              </a:ext>
-            </a:extLst>
-          </p:cNvPr>
-          <p:cNvSpPr txBox="1">
-            <a:spLocks noGrp="1"/>
-          </p:cNvSpPr>
-          <p:nvPr>
-            <p:ph type="body" idx="1"/>
-          </p:nvPr>
-        </p:nvSpPr>
-        <p:spPr>
-          <a:xfrm>
-            <a:off x="685800" y="4343400"/>
-            <a:ext cx="5486400" cy="4114800"/>
-          </a:xfrm>
-          <a:prstGeom prst="rect">
-            <a:avLst/>
-          </a:prstGeom>
-        </p:spPr>
-        <p:txBody>
-          <a:bodyPr spcFirstLastPara="1" wrap="square" lIns="91425" tIns="91425" rIns="91425" bIns="91425" anchor="t" anchorCtr="0">
-            <a:noAutofit/>
-          </a:bodyPr>
-          <a:lstStyle/>
-          <a:p>
-            <a:pPr marL="0" lvl="0" indent="0" algn="l" rtl="0">
-              <a:spcBef>
-                <a:spcPts val="0"/>
-              </a:spcBef>
-              <a:spcAft>
-                <a:spcPts val="0"/>
-              </a:spcAft>
-              <a:buNone/>
-            </a:pPr>
-            <a:endParaRPr/>
-          </a:p>
-        </p:txBody>
-      </p:sp>
-      <p:sp>
-        <p:nvSpPr>
-          <p:cNvPr id="353" name="Google Shape;353;g364a009736c_2_267:notes">
-            <a:extLst>
-              <a:ext uri="{FF2B5EF4-FFF2-40B4-BE49-F238E27FC236}">
-                <a16:creationId xmlns:a16="http://schemas.microsoft.com/office/drawing/2014/main" id="{BA4593AD-D636-0929-A118-52287718C569}"/>
-              </a:ext>
-            </a:extLst>
-          </p:cNvPr>
-          <p:cNvSpPr>
-            <a:spLocks noGrp="1" noRot="1" noChangeAspect="1"/>
-          </p:cNvSpPr>
-          <p:nvPr>
-            <p:ph type="sldImg" idx="2"/>
-          </p:nvPr>
-        </p:nvSpPr>
-        <p:spPr>
-          <a:xfrm>
-            <a:off x="381000" y="685800"/>
-            <a:ext cx="6096000" cy="3429000"/>
-          </a:xfrm>
-          <a:custGeom>
-            <a:avLst/>
-            <a:gdLst/>
-            <a:ahLst/>
-            <a:cxnLst/>
-            <a:rect l="l" t="t" r="r" b="b"/>
-            <a:pathLst>
-              <a:path w="120000" h="120000" extrusionOk="0">
-                <a:moveTo>
-                  <a:pt x="0" y="0"/>
-                </a:moveTo>
-                <a:lnTo>
-                  <a:pt x="120000" y="0"/>
-                </a:lnTo>
-                <a:lnTo>
-                  <a:pt x="120000" y="120000"/>
-                </a:lnTo>
-                <a:lnTo>
-                  <a:pt x="0" y="120000"/>
-                </a:lnTo>
-                <a:close/>
-              </a:path>
-            </a:pathLst>
-          </a:custGeom>
-        </p:spPr>
-      </p:sp>
-    </p:spTree>
-    <p:extLst>
-      <p:ext uri="{BB962C8B-B14F-4D97-AF65-F5344CB8AC3E}">
-        <p14:creationId xmlns:p14="http://schemas.microsoft.com/office/powerpoint/2010/main" val="1546419728"/>
-      </p:ext>
-    </p:extLst>
   </p:cSld>
   <p:clrMapOvr>
     <a:masterClrMapping/>
@@ -4344,7 +4458,7 @@
           <a:p>
             <a:fld id="{7A3E0868-4E26-4CDC-8A56-D70E2D8B12FE}" type="datetime3">
               <a:rPr lang="en-US" smtClean="0"/>
-              <a:t>9 July 2026</a:t>
+              <a:t>10 July 2026</a:t>
             </a:fld>
             <a:endParaRPr lang="en-US"/>
           </a:p>
@@ -6905,7 +7019,7 @@
           <a:p>
             <a:fld id="{A7B8021B-6105-4216-96FC-94348F216D0E}" type="datetime3">
               <a:rPr lang="en-US" smtClean="0"/>
-              <a:t>9 July 2026</a:t>
+              <a:t>10 July 2026</a:t>
             </a:fld>
             <a:endParaRPr lang="en-US"/>
           </a:p>
@@ -8602,7 +8716,7 @@
           <a:p>
             <a:fld id="{5D27CFAB-73E6-44A8-B862-B3306344E3F2}" type="datetime3">
               <a:rPr lang="en-US" smtClean="0"/>
-              <a:t>9 July 2026</a:t>
+              <a:t>10 July 2026</a:t>
             </a:fld>
             <a:endParaRPr lang="en-US"/>
           </a:p>
@@ -10392,7 +10506,7 @@
           <a:p>
             <a:fld id="{A9B2E784-A5F5-4301-881B-94AC8DBF9DED}" type="datetime3">
               <a:rPr lang="en-US" smtClean="0"/>
-              <a:t>9 July 2026</a:t>
+              <a:t>10 July 2026</a:t>
             </a:fld>
             <a:endParaRPr lang="en-US"/>
           </a:p>
@@ -10571,7 +10685,7 @@
           <a:p>
             <a:fld id="{18EAB3A5-9E92-4BB9-8F22-9632B4FBEDBA}" type="datetime3">
               <a:rPr lang="en-US" smtClean="0"/>
-              <a:t>9 July 2026</a:t>
+              <a:t>10 July 2026</a:t>
             </a:fld>
             <a:endParaRPr lang="en-US"/>
           </a:p>
@@ -10798,7 +10912,7 @@
           <a:p>
             <a:fld id="{40923810-5FB2-48C9-96CA-1DE2C4773142}" type="datetime3">
               <a:rPr lang="en-US" smtClean="0"/>
-              <a:t>9 July 2026</a:t>
+              <a:t>10 July 2026</a:t>
             </a:fld>
             <a:endParaRPr lang="en-US"/>
           </a:p>
@@ -11088,7 +11202,7 @@
           <a:p>
             <a:fld id="{E50EFF4B-86EB-42FB-93EA-7D8F9CB2466F}" type="datetime3">
               <a:rPr lang="en-US" smtClean="0"/>
-              <a:t>9 July 2026</a:t>
+              <a:t>10 July 2026</a:t>
             </a:fld>
             <a:endParaRPr lang="en-US"/>
           </a:p>
@@ -11700,7 +11814,7 @@
           <a:p>
             <a:fld id="{FB14FC24-E041-45E9-9A72-E5755A86890F}" type="datetime3">
               <a:rPr lang="en-US" smtClean="0"/>
-              <a:t>9 July 2026</a:t>
+              <a:t>10 July 2026</a:t>
             </a:fld>
             <a:endParaRPr lang="en-US"/>
           </a:p>
@@ -12560,7 +12674,7 @@
           <a:p>
             <a:fld id="{98A19125-94A7-4474-858C-FD9C4ABE9DDA}" type="datetime3">
               <a:rPr lang="en-US" smtClean="0"/>
-              <a:t>9 July 2026</a:t>
+              <a:t>10 July 2026</a:t>
             </a:fld>
             <a:endParaRPr lang="en-US"/>
           </a:p>
@@ -13663,7 +13777,7 @@
           <a:p>
             <a:fld id="{3BA0343D-C8D8-43CE-BB79-50DEA219DB07}" type="datetime3">
               <a:rPr lang="en-US" smtClean="0"/>
-              <a:t>9 July 2026</a:t>
+              <a:t>10 July 2026</a:t>
             </a:fld>
             <a:endParaRPr lang="en-US"/>
           </a:p>
@@ -13952,7 +14066,7 @@
           <a:p>
             <a:fld id="{453BD212-0B9F-4987-965F-AC83B2FC354F}" type="datetime3">
               <a:rPr lang="en-US" smtClean="0"/>
-              <a:t>9 July 2026</a:t>
+              <a:t>10 July 2026</a:t>
             </a:fld>
             <a:endParaRPr lang="en-US"/>
           </a:p>
@@ -14197,7 +14311,7 @@
           <a:p>
             <a:fld id="{6DDC931E-8CBE-4A3F-A034-9B6122C6DCDB}" type="datetime3">
               <a:rPr lang="en-US" smtClean="0"/>
-              <a:t>9 July 2026</a:t>
+              <a:t>10 July 2026</a:t>
             </a:fld>
             <a:endParaRPr lang="en-US"/>
           </a:p>
@@ -15963,7 +16077,7 @@
           <a:p>
             <a:fld id="{220AF9C2-5E8A-4308-AE6B-CA9B65007D0E}" type="datetime3">
               <a:rPr lang="en-US" smtClean="0"/>
-              <a:t>9 July 2026</a:t>
+              <a:t>10 July 2026</a:t>
             </a:fld>
             <a:endParaRPr lang="en-US"/>
           </a:p>
@@ -16276,7 +16390,7 @@
           <a:p>
             <a:fld id="{FF31E861-D2AF-431D-860B-DCF67C218052}" type="datetime3">
               <a:rPr lang="en-US" smtClean="0"/>
-              <a:t>9 July 2026</a:t>
+              <a:t>10 July 2026</a:t>
             </a:fld>
             <a:endParaRPr lang="en-US"/>
           </a:p>
@@ -16555,7 +16669,7 @@
           <a:p>
             <a:fld id="{D1DA25B2-AAF1-4C1F-AA38-12D5BFA7D4C8}" type="datetime3">
               <a:rPr lang="en-US" smtClean="0"/>
-              <a:t>9 July 2026</a:t>
+              <a:t>10 July 2026</a:t>
             </a:fld>
             <a:endParaRPr lang="en-US"/>
           </a:p>
@@ -16834,7 +16948,7 @@
           <a:p>
             <a:fld id="{A25C0F39-45D0-48E9-90B3-7FE8FCE561C8}" type="datetime3">
               <a:rPr lang="en-US" smtClean="0"/>
-              <a:t>9 July 2026</a:t>
+              <a:t>10 July 2026</a:t>
             </a:fld>
             <a:endParaRPr lang="en-US"/>
           </a:p>
@@ -17335,7 +17449,7 @@
           <a:p>
             <a:fld id="{9BAF1A3D-92FA-4F24-9781-74AFA516A230}" type="datetime3">
               <a:rPr lang="en-US" smtClean="0"/>
-              <a:t>9 July 2026</a:t>
+              <a:t>10 July 2026</a:t>
             </a:fld>
             <a:endParaRPr lang="en-US"/>
           </a:p>
@@ -17462,7 +17576,7 @@
           <a:p>
             <a:fld id="{5719C672-856D-4617-A693-8FE15749A9B7}" type="datetime3">
               <a:rPr lang="en-US" smtClean="0"/>
-              <a:t>9 July 2026</a:t>
+              <a:t>10 July 2026</a:t>
             </a:fld>
             <a:endParaRPr lang="en-US"/>
           </a:p>
@@ -17597,7 +17711,7 @@
           <a:p>
             <a:fld id="{5F6C764D-A39E-4C03-B161-E0BC66E8883B}" type="datetime3">
               <a:rPr lang="en-US" smtClean="0"/>
-              <a:t>9 July 2026</a:t>
+              <a:t>10 July 2026</a:t>
             </a:fld>
             <a:endParaRPr lang="en-US"/>
           </a:p>
@@ -17839,7 +17953,7 @@
           <a:p>
             <a:fld id="{6E3E33F9-20B7-4995-BE7D-165DBB597850}" type="datetime3">
               <a:rPr lang="en-US" smtClean="0"/>
-              <a:t>9 July 2026</a:t>
+              <a:t>10 July 2026</a:t>
             </a:fld>
             <a:endParaRPr lang="en-US"/>
           </a:p>
@@ -17952,7 +18066,7 @@
           <a:p>
             <a:fld id="{CD41C263-3501-4369-A962-62B6BF915CDE}" type="datetime3">
               <a:rPr lang="en-US" smtClean="0"/>
-              <a:t>9 July 2026</a:t>
+              <a:t>10 July 2026</a:t>
             </a:fld>
             <a:endParaRPr lang="en-US"/>
           </a:p>
@@ -18355,7 +18469,7 @@
           <a:p>
             <a:fld id="{B06F3EBE-B2E8-4992-9F00-9E4B44F057C0}" type="datetime3">
               <a:rPr lang="en-US" smtClean="0"/>
-              <a:t>9 July 2026</a:t>
+              <a:t>10 July 2026</a:t>
             </a:fld>
             <a:endParaRPr lang="en-US"/>
           </a:p>
@@ -18487,7 +18601,7 @@
           <a:p>
             <a:fld id="{D41656AB-D2E1-472E-8B95-0DF5C6E1D623}" type="datetime3">
               <a:rPr lang="en-US" smtClean="0"/>
-              <a:t>9 July 2026</a:t>
+              <a:t>10 July 2026</a:t>
             </a:fld>
             <a:endParaRPr lang="en-US"/>
           </a:p>
@@ -22628,7 +22742,7 @@
           <a:p>
             <a:fld id="{AD622D1A-DF83-41A8-85FF-04D90BF831D3}" type="datetime3">
               <a:rPr lang="en-US" smtClean="0"/>
-              <a:t>9 July 2026</a:t>
+              <a:t>10 July 2026</a:t>
             </a:fld>
             <a:endParaRPr lang="en-US"/>
           </a:p>
@@ -22878,7 +22992,7 @@
           <a:p>
             <a:fld id="{334F72C3-CDF3-44A8-B602-1649B1728485}" type="datetime3">
               <a:rPr lang="en-US" smtClean="0"/>
-              <a:t>9 July 2026</a:t>
+              <a:t>10 July 2026</a:t>
             </a:fld>
             <a:endParaRPr lang="en-US"/>
           </a:p>
@@ -23185,7 +23299,7 @@
           <a:p>
             <a:fld id="{1E0132BA-B5E7-4FFD-AF6C-169169D47D4A}" type="datetime3">
               <a:rPr lang="en-US" smtClean="0"/>
-              <a:t>9 July 2026</a:t>
+              <a:t>10 July 2026</a:t>
             </a:fld>
             <a:endParaRPr lang="en-US"/>
           </a:p>
@@ -23666,7 +23780,7 @@
           <a:p>
             <a:fld id="{81A30091-1C2A-4151-8D3C-D1E47A72615F}" type="datetime3">
               <a:rPr lang="en-US" smtClean="0"/>
-              <a:t>9 July 2026</a:t>
+              <a:t>10 July 2026</a:t>
             </a:fld>
             <a:endParaRPr lang="en-US"/>
           </a:p>
@@ -24303,7 +24417,7 @@
           <a:p>
             <a:fld id="{35D703CE-07B4-4C05-A488-B4566700621F}" type="datetime3">
               <a:rPr lang="en-US" smtClean="0"/>
-              <a:t>9 July 2026</a:t>
+              <a:t>10 July 2026</a:t>
             </a:fld>
             <a:endParaRPr lang="en-US"/>
           </a:p>
@@ -25361,7 +25475,7 @@
           <a:p>
             <a:fld id="{694BD61C-20BA-43AF-A21F-1DAFB3200099}" type="datetime3">
               <a:rPr lang="en-US" smtClean="0"/>
-              <a:t>9 July 2026</a:t>
+              <a:t>10 July 2026</a:t>
             </a:fld>
             <a:endParaRPr lang="en-US"/>
           </a:p>
@@ -25848,7 +25962,7 @@
           <a:p>
             <a:fld id="{CABCB1B0-B6E5-4DD1-BB55-95C076D6C0C8}" type="datetime3">
               <a:rPr lang="en-US" smtClean="0"/>
-              <a:t>9 July 2026</a:t>
+              <a:t>10 July 2026</a:t>
             </a:fld>
             <a:endParaRPr lang="en-US"/>
           </a:p>
@@ -26796,6 +26910,401 @@
   <p:cSld>
     <p:spTree>
       <p:nvGrpSpPr>
+        <p:cNvPr id="1" name=""/>
+        <p:cNvGrpSpPr/>
+        <p:nvPr/>
+      </p:nvGrpSpPr>
+      <p:grpSpPr>
+        <a:xfrm>
+          <a:off x="0" y="0"/>
+          <a:ext cx="0" cy="0"/>
+          <a:chOff x="0" y="0"/>
+          <a:chExt cx="0" cy="0"/>
+        </a:xfrm>
+      </p:grpSpPr>
+      <p:sp>
+        <p:nvSpPr>
+          <p:cNvPr id="2" name="Title 1">
+            <a:extLst>
+              <a:ext uri="{FF2B5EF4-FFF2-40B4-BE49-F238E27FC236}">
+                <a16:creationId xmlns:a16="http://schemas.microsoft.com/office/drawing/2014/main" id="{C2A42DED-686C-354A-03AA-8C3105239CF9}"/>
+              </a:ext>
+            </a:extLst>
+          </p:cNvPr>
+          <p:cNvSpPr>
+            <a:spLocks noGrp="1"/>
+          </p:cNvSpPr>
+          <p:nvPr>
+            <p:ph type="title"/>
+          </p:nvPr>
+        </p:nvSpPr>
+        <p:spPr/>
+        <p:txBody>
+          <a:bodyPr/>
+          <a:lstStyle/>
+          <a:p>
+            <a:r>
+              <a:rPr lang="en-US" dirty="0"/>
+              <a:t>Spot the Difference</a:t>
+            </a:r>
+          </a:p>
+        </p:txBody>
+      </p:sp>
+      <p:sp>
+        <p:nvSpPr>
+          <p:cNvPr id="3" name="Content Placeholder 2">
+            <a:extLst>
+              <a:ext uri="{FF2B5EF4-FFF2-40B4-BE49-F238E27FC236}">
+                <a16:creationId xmlns:a16="http://schemas.microsoft.com/office/drawing/2014/main" id="{C03A03FA-440C-E5A0-88B6-F6D53B839E7C}"/>
+              </a:ext>
+            </a:extLst>
+          </p:cNvPr>
+          <p:cNvSpPr>
+            <a:spLocks noGrp="1"/>
+          </p:cNvSpPr>
+          <p:nvPr>
+            <p:ph sz="half" idx="1"/>
+          </p:nvPr>
+        </p:nvSpPr>
+        <p:spPr/>
+        <p:txBody>
+          <a:bodyPr/>
+          <a:lstStyle/>
+          <a:p>
+            <a:endParaRPr lang="en-US" dirty="0"/>
+          </a:p>
+          <a:p>
+            <a:endParaRPr lang="en-US" dirty="0"/>
+          </a:p>
+          <a:p>
+            <a:endParaRPr lang="en-US" dirty="0"/>
+          </a:p>
+          <a:p>
+            <a:r>
+              <a:rPr lang="en-US" dirty="0"/>
+              <a:t>01100011011011110110111101101100</a:t>
+            </a:r>
+          </a:p>
+          <a:p>
+            <a:r>
+              <a:rPr lang="en-US" dirty="0"/>
+              <a:t>01100011011011110110111101101100</a:t>
+            </a:r>
+          </a:p>
+          <a:p>
+            <a:r>
+              <a:rPr lang="en-US" dirty="0"/>
+              <a:t>01100011011011110110111101101100</a:t>
+            </a:r>
+          </a:p>
+        </p:txBody>
+      </p:sp>
+      <p:sp>
+        <p:nvSpPr>
+          <p:cNvPr id="4" name="Content Placeholder 3">
+            <a:extLst>
+              <a:ext uri="{FF2B5EF4-FFF2-40B4-BE49-F238E27FC236}">
+                <a16:creationId xmlns:a16="http://schemas.microsoft.com/office/drawing/2014/main" id="{CC29AC81-FB1F-9F08-D768-CB1A89B82987}"/>
+              </a:ext>
+            </a:extLst>
+          </p:cNvPr>
+          <p:cNvSpPr>
+            <a:spLocks noGrp="1"/>
+          </p:cNvSpPr>
+          <p:nvPr>
+            <p:ph sz="half" idx="2"/>
+          </p:nvPr>
+        </p:nvSpPr>
+        <p:spPr/>
+        <p:txBody>
+          <a:bodyPr/>
+          <a:lstStyle/>
+          <a:p>
+            <a:endParaRPr lang="en-US" dirty="0"/>
+          </a:p>
+          <a:p>
+            <a:endParaRPr lang="en-US" dirty="0"/>
+          </a:p>
+          <a:p>
+            <a:endParaRPr lang="en-US" dirty="0"/>
+          </a:p>
+          <a:p>
+            <a:r>
+              <a:rPr lang="en-US" dirty="0"/>
+              <a:t>1,668,247,404 (int)</a:t>
+            </a:r>
+          </a:p>
+          <a:p>
+            <a:r>
+              <a:rPr lang="en-US" dirty="0"/>
+              <a:t>4.4168006258522776e+21 (float)</a:t>
+            </a:r>
+          </a:p>
+          <a:p>
+            <a:r>
+              <a:rPr lang="en-US" dirty="0"/>
+              <a:t>"cool" (string)</a:t>
+            </a:r>
+          </a:p>
+        </p:txBody>
+      </p:sp>
+      <p:sp>
+        <p:nvSpPr>
+          <p:cNvPr id="5" name="Date Placeholder 4">
+            <a:extLst>
+              <a:ext uri="{FF2B5EF4-FFF2-40B4-BE49-F238E27FC236}">
+                <a16:creationId xmlns:a16="http://schemas.microsoft.com/office/drawing/2014/main" id="{D71B38C4-45F3-1654-A84A-E5E00E36AC46}"/>
+              </a:ext>
+            </a:extLst>
+          </p:cNvPr>
+          <p:cNvSpPr>
+            <a:spLocks noGrp="1"/>
+          </p:cNvSpPr>
+          <p:nvPr>
+            <p:ph type="dt" sz="half" idx="10"/>
+          </p:nvPr>
+        </p:nvSpPr>
+        <p:spPr/>
+        <p:txBody>
+          <a:bodyPr/>
+          <a:lstStyle/>
+          <a:p>
+            <a:fld id="{334F72C3-CDF3-44A8-B602-1649B1728485}" type="datetime3">
+              <a:rPr lang="en-US" smtClean="0"/>
+              <a:t>10 July 2026</a:t>
+            </a:fld>
+            <a:endParaRPr lang="en-US"/>
+          </a:p>
+        </p:txBody>
+      </p:sp>
+      <p:sp>
+        <p:nvSpPr>
+          <p:cNvPr id="6" name="Slide Number Placeholder 5">
+            <a:extLst>
+              <a:ext uri="{FF2B5EF4-FFF2-40B4-BE49-F238E27FC236}">
+                <a16:creationId xmlns:a16="http://schemas.microsoft.com/office/drawing/2014/main" id="{6A8CE803-317A-C6AF-DB96-475300B4CBF7}"/>
+              </a:ext>
+            </a:extLst>
+          </p:cNvPr>
+          <p:cNvSpPr>
+            <a:spLocks noGrp="1"/>
+          </p:cNvSpPr>
+          <p:nvPr>
+            <p:ph type="sldNum" sz="quarter" idx="11"/>
+          </p:nvPr>
+        </p:nvSpPr>
+        <p:spPr/>
+        <p:txBody>
+          <a:bodyPr/>
+          <a:lstStyle/>
+          <a:p>
+            <a:fld id="{64E5BE4B-2FBF-4174-9E62-85FAD1CB43A6}" type="slidenum">
+              <a:rPr lang="en-US" smtClean="0"/>
+              <a:pPr/>
+              <a:t>10</a:t>
+            </a:fld>
+            <a:endParaRPr lang="en-US"/>
+          </a:p>
+        </p:txBody>
+      </p:sp>
+    </p:spTree>
+    <p:extLst>
+      <p:ext uri="{BB962C8B-B14F-4D97-AF65-F5344CB8AC3E}">
+        <p14:creationId xmlns:p14="http://schemas.microsoft.com/office/powerpoint/2010/main" val="3848003108"/>
+      </p:ext>
+    </p:extLst>
+  </p:cSld>
+  <p:clrMapOvr>
+    <a:masterClrMapping/>
+  </p:clrMapOvr>
+  <p:timing>
+    <p:tnLst>
+      <p:par>
+        <p:cTn id="1" dur="indefinite" restart="never" nodeType="tmRoot">
+          <p:childTnLst>
+            <p:seq concurrent="1" nextAc="seek">
+              <p:cTn id="2" dur="indefinite" nodeType="mainSeq">
+                <p:childTnLst>
+                  <p:par>
+                    <p:cTn id="3" fill="hold">
+                      <p:stCondLst>
+                        <p:cond delay="indefinite"/>
+                      </p:stCondLst>
+                      <p:childTnLst>
+                        <p:par>
+                          <p:cTn id="4" fill="hold">
+                            <p:stCondLst>
+                              <p:cond delay="0"/>
+                            </p:stCondLst>
+                            <p:childTnLst>
+                              <p:par>
+                                <p:cTn id="5" presetID="1" presetClass="entr" presetSubtype="0" fill="hold" grpId="0" nodeType="clickEffect">
+                                  <p:stCondLst>
+                                    <p:cond delay="0"/>
+                                  </p:stCondLst>
+                                  <p:childTnLst>
+                                    <p:set>
+                                      <p:cBhvr>
+                                        <p:cTn id="6" dur="1" fill="hold">
+                                          <p:stCondLst>
+                                            <p:cond delay="0"/>
+                                          </p:stCondLst>
+                                        </p:cTn>
+                                        <p:tgtEl>
+                                          <p:spTgt spid="4">
+                                            <p:txEl>
+                                              <p:pRg st="3" end="3"/>
+                                            </p:txEl>
+                                          </p:spTgt>
+                                        </p:tgtEl>
+                                        <p:attrNameLst>
+                                          <p:attrName>style.visibility</p:attrName>
+                                        </p:attrNameLst>
+                                      </p:cBhvr>
+                                      <p:to>
+                                        <p:strVal val="visible"/>
+                                      </p:to>
+                                    </p:set>
+                                  </p:childTnLst>
+                                </p:cTn>
+                              </p:par>
+                            </p:childTnLst>
+                          </p:cTn>
+                        </p:par>
+                      </p:childTnLst>
+                    </p:cTn>
+                  </p:par>
+                  <p:par>
+                    <p:cTn id="7" fill="hold">
+                      <p:stCondLst>
+                        <p:cond delay="indefinite"/>
+                      </p:stCondLst>
+                      <p:childTnLst>
+                        <p:par>
+                          <p:cTn id="8" fill="hold">
+                            <p:stCondLst>
+                              <p:cond delay="0"/>
+                            </p:stCondLst>
+                            <p:childTnLst>
+                              <p:par>
+                                <p:cTn id="9" presetID="1" presetClass="entr" presetSubtype="0" fill="hold" grpId="0" nodeType="clickEffect">
+                                  <p:stCondLst>
+                                    <p:cond delay="0"/>
+                                  </p:stCondLst>
+                                  <p:childTnLst>
+                                    <p:set>
+                                      <p:cBhvr>
+                                        <p:cTn id="10" dur="1" fill="hold">
+                                          <p:stCondLst>
+                                            <p:cond delay="0"/>
+                                          </p:stCondLst>
+                                        </p:cTn>
+                                        <p:tgtEl>
+                                          <p:spTgt spid="4">
+                                            <p:txEl>
+                                              <p:pRg st="4" end="4"/>
+                                            </p:txEl>
+                                          </p:spTgt>
+                                        </p:tgtEl>
+                                        <p:attrNameLst>
+                                          <p:attrName>style.visibility</p:attrName>
+                                        </p:attrNameLst>
+                                      </p:cBhvr>
+                                      <p:to>
+                                        <p:strVal val="visible"/>
+                                      </p:to>
+                                    </p:set>
+                                  </p:childTnLst>
+                                </p:cTn>
+                              </p:par>
+                            </p:childTnLst>
+                          </p:cTn>
+                        </p:par>
+                      </p:childTnLst>
+                    </p:cTn>
+                  </p:par>
+                  <p:par>
+                    <p:cTn id="11" fill="hold">
+                      <p:stCondLst>
+                        <p:cond delay="indefinite"/>
+                      </p:stCondLst>
+                      <p:childTnLst>
+                        <p:par>
+                          <p:cTn id="12" fill="hold">
+                            <p:stCondLst>
+                              <p:cond delay="0"/>
+                            </p:stCondLst>
+                            <p:childTnLst>
+                              <p:par>
+                                <p:cTn id="13" presetID="1" presetClass="entr" presetSubtype="0" fill="hold" grpId="0" nodeType="clickEffect">
+                                  <p:stCondLst>
+                                    <p:cond delay="0"/>
+                                  </p:stCondLst>
+                                  <p:childTnLst>
+                                    <p:set>
+                                      <p:cBhvr>
+                                        <p:cTn id="14" dur="1" fill="hold">
+                                          <p:stCondLst>
+                                            <p:cond delay="0"/>
+                                          </p:stCondLst>
+                                        </p:cTn>
+                                        <p:tgtEl>
+                                          <p:spTgt spid="4">
+                                            <p:txEl>
+                                              <p:pRg st="5" end="5"/>
+                                            </p:txEl>
+                                          </p:spTgt>
+                                        </p:tgtEl>
+                                        <p:attrNameLst>
+                                          <p:attrName>style.visibility</p:attrName>
+                                        </p:attrNameLst>
+                                      </p:cBhvr>
+                                      <p:to>
+                                        <p:strVal val="visible"/>
+                                      </p:to>
+                                    </p:set>
+                                  </p:childTnLst>
+                                </p:cTn>
+                              </p:par>
+                            </p:childTnLst>
+                          </p:cTn>
+                        </p:par>
+                      </p:childTnLst>
+                    </p:cTn>
+                  </p:par>
+                </p:childTnLst>
+              </p:cTn>
+              <p:prevCondLst>
+                <p:cond evt="onPrev" delay="0">
+                  <p:tgtEl>
+                    <p:sldTgt/>
+                  </p:tgtEl>
+                </p:cond>
+              </p:prevCondLst>
+              <p:nextCondLst>
+                <p:cond evt="onNext" delay="0">
+                  <p:tgtEl>
+                    <p:sldTgt/>
+                  </p:tgtEl>
+                </p:cond>
+              </p:nextCondLst>
+            </p:seq>
+          </p:childTnLst>
+        </p:cTn>
+      </p:par>
+    </p:tnLst>
+    <p:bldLst>
+      <p:bldP spid="4" grpId="0" build="p"/>
+    </p:bldLst>
+  </p:timing>
+</p:sld>
+</file>
+
+<file path=ppt/slides/slide11.xml><?xml version="1.0" encoding="utf-8"?>
+<p:sld xmlns:a="http://schemas.openxmlformats.org/drawingml/2006/main" xmlns:r="http://schemas.openxmlformats.org/officeDocument/2006/relationships" xmlns:p="http://schemas.openxmlformats.org/presentationml/2006/main">
+  <p:cSld>
+    <p:spTree>
+      <p:nvGrpSpPr>
         <p:cNvPr id="1" name="Shape 311"/>
         <p:cNvGrpSpPr/>
         <p:nvPr/>
@@ -27233,7 +27742,7 @@
 </p:sld>
 </file>
 
-<file path=ppt/slides/slide11.xml><?xml version="1.0" encoding="utf-8"?>
+<file path=ppt/slides/slide12.xml><?xml version="1.0" encoding="utf-8"?>
 <p:sld xmlns:a="http://schemas.openxmlformats.org/drawingml/2006/main" xmlns:r="http://schemas.openxmlformats.org/officeDocument/2006/relationships" xmlns:p="http://schemas.openxmlformats.org/presentationml/2006/main">
   <p:cSld>
     <p:spTree>
@@ -28800,7 +29309,7 @@
 </p:sld>
 </file>
 
-<file path=ppt/slides/slide12.xml><?xml version="1.0" encoding="utf-8"?>
+<file path=ppt/slides/slide13.xml><?xml version="1.0" encoding="utf-8"?>
 <p:sld xmlns:a="http://schemas.openxmlformats.org/drawingml/2006/main" xmlns:r="http://schemas.openxmlformats.org/officeDocument/2006/relationships" xmlns:p="http://schemas.openxmlformats.org/presentationml/2006/main">
   <p:cSld>
     <p:spTree>
@@ -30387,7 +30896,7 @@
 </p:sld>
 </file>
 
-<file path=ppt/slides/slide13.xml><?xml version="1.0" encoding="utf-8"?>
+<file path=ppt/slides/slide14.xml><?xml version="1.0" encoding="utf-8"?>
 <p:sld xmlns:a="http://schemas.openxmlformats.org/drawingml/2006/main" xmlns:r="http://schemas.openxmlformats.org/officeDocument/2006/relationships" xmlns:p="http://schemas.openxmlformats.org/presentationml/2006/main">
   <p:cSld>
     <p:spTree>
@@ -32285,7 +32794,7 @@
 </p:sld>
 </file>
 
-<file path=ppt/slides/slide14.xml><?xml version="1.0" encoding="utf-8"?>
+<file path=ppt/slides/slide15.xml><?xml version="1.0" encoding="utf-8"?>
 <p:sld xmlns:a="http://schemas.openxmlformats.org/drawingml/2006/main" xmlns:r="http://schemas.openxmlformats.org/officeDocument/2006/relationships" xmlns:p="http://schemas.openxmlformats.org/presentationml/2006/main">
   <p:cSld>
     <p:spTree>
@@ -33413,7 +33922,7 @@
 </p:sld>
 </file>
 
-<file path=ppt/slides/slide15.xml><?xml version="1.0" encoding="utf-8"?>
+<file path=ppt/slides/slide16.xml><?xml version="1.0" encoding="utf-8"?>
 <p:sld xmlns:a="http://schemas.openxmlformats.org/drawingml/2006/main" xmlns:r="http://schemas.openxmlformats.org/officeDocument/2006/relationships" xmlns:p="http://schemas.openxmlformats.org/presentationml/2006/main">
   <p:cSld>
     <p:spTree>
@@ -33748,7 +34257,7 @@
 </p:sld>
 </file>
 
-<file path=ppt/slides/slide16.xml><?xml version="1.0" encoding="utf-8"?>
+<file path=ppt/slides/slide17.xml><?xml version="1.0" encoding="utf-8"?>
 <p:sld xmlns:a="http://schemas.openxmlformats.org/drawingml/2006/main" xmlns:r="http://schemas.openxmlformats.org/officeDocument/2006/relationships" xmlns:p="http://schemas.openxmlformats.org/presentationml/2006/main">
   <p:cSld>
     <p:spTree>
@@ -33823,7 +34332,7 @@
           <a:p>
             <a:fld id="{334F72C3-CDF3-44A8-B602-1649B1728485}" type="datetime3">
               <a:rPr lang="en-US" smtClean="0"/>
-              <a:t>9 July 2026</a:t>
+              <a:t>10 July 2026</a:t>
             </a:fld>
             <a:endParaRPr lang="en-US"/>
           </a:p>
@@ -33853,7 +34362,7 @@
             <a:fld id="{64E5BE4B-2FBF-4174-9E62-85FAD1CB43A6}" type="slidenum">
               <a:rPr lang="en-US" smtClean="0"/>
               <a:pPr/>
-              <a:t>16</a:t>
+              <a:t>17</a:t>
             </a:fld>
             <a:endParaRPr lang="en-US"/>
           </a:p>
@@ -33872,7 +34381,7 @@
 </p:sld>
 </file>
 
-<file path=ppt/slides/slide17.xml><?xml version="1.0" encoding="utf-8"?>
+<file path=ppt/slides/slide18.xml><?xml version="1.0" encoding="utf-8"?>
 <p:sld xmlns:a="http://schemas.openxmlformats.org/drawingml/2006/main" xmlns:r="http://schemas.openxmlformats.org/officeDocument/2006/relationships" xmlns:p="http://schemas.openxmlformats.org/presentationml/2006/main">
   <p:cSld>
     <p:spTree>
@@ -34005,7 +34514,7 @@
           <a:p>
             <a:fld id="{AD622D1A-DF83-41A8-85FF-04D90BF831D3}" type="datetime3">
               <a:rPr lang="en-US" smtClean="0"/>
-              <a:t>9 July 2026</a:t>
+              <a:t>10 July 2026</a:t>
             </a:fld>
             <a:endParaRPr lang="en-US"/>
           </a:p>
@@ -34035,7 +34544,7 @@
             <a:fld id="{64E5BE4B-2FBF-4174-9E62-85FAD1CB43A6}" type="slidenum">
               <a:rPr lang="en-US" smtClean="0"/>
               <a:pPr/>
-              <a:t>17</a:t>
+              <a:t>18</a:t>
             </a:fld>
             <a:endParaRPr lang="en-US"/>
           </a:p>
@@ -35190,7 +35699,7 @@
 </p:sld>
 </file>
 
-<file path=ppt/slides/slide18.xml><?xml version="1.0" encoding="utf-8"?>
+<file path=ppt/slides/slide19.xml><?xml version="1.0" encoding="utf-8"?>
 <p:sld xmlns:a="http://schemas.openxmlformats.org/drawingml/2006/main" xmlns:r="http://schemas.openxmlformats.org/officeDocument/2006/relationships" xmlns:p="http://schemas.openxmlformats.org/presentationml/2006/main">
   <p:cSld>
     <p:spTree>
@@ -35340,7 +35849,7 @@
           <a:p>
             <a:fld id="{AD622D1A-DF83-41A8-85FF-04D90BF831D3}" type="datetime3">
               <a:rPr lang="en-US" smtClean="0"/>
-              <a:t>9 July 2026</a:t>
+              <a:t>10 July 2026</a:t>
             </a:fld>
             <a:endParaRPr lang="en-US"/>
           </a:p>
@@ -35370,7 +35879,7 @@
             <a:fld id="{64E5BE4B-2FBF-4174-9E62-85FAD1CB43A6}" type="slidenum">
               <a:rPr lang="en-US" smtClean="0"/>
               <a:pPr/>
-              <a:t>18</a:t>
+              <a:t>19</a:t>
             </a:fld>
             <a:endParaRPr lang="en-US"/>
           </a:p>
@@ -35696,7 +36205,457 @@
 </p:sld>
 </file>
 
-<file path=ppt/slides/slide19.xml><?xml version="1.0" encoding="utf-8"?>
+<file path=ppt/slides/slide2.xml><?xml version="1.0" encoding="utf-8"?>
+<p:sld xmlns:a="http://schemas.openxmlformats.org/drawingml/2006/main" xmlns:r="http://schemas.openxmlformats.org/officeDocument/2006/relationships" xmlns:p="http://schemas.openxmlformats.org/presentationml/2006/main">
+  <p:cSld>
+    <p:spTree>
+      <p:nvGrpSpPr>
+        <p:cNvPr id="1" name="Shape 259">
+          <a:extLst>
+            <a:ext uri="{FF2B5EF4-FFF2-40B4-BE49-F238E27FC236}">
+              <a16:creationId xmlns:a16="http://schemas.microsoft.com/office/drawing/2014/main" id="{341FB50C-5882-3994-477F-1ACB25D0968F}"/>
+            </a:ext>
+          </a:extLst>
+        </p:cNvPr>
+        <p:cNvGrpSpPr/>
+        <p:nvPr/>
+      </p:nvGrpSpPr>
+      <p:grpSpPr>
+        <a:xfrm>
+          <a:off x="0" y="0"/>
+          <a:ext cx="0" cy="0"/>
+          <a:chOff x="0" y="0"/>
+          <a:chExt cx="0" cy="0"/>
+        </a:xfrm>
+      </p:grpSpPr>
+      <p:sp>
+        <p:nvSpPr>
+          <p:cNvPr id="5" name="Title 4">
+            <a:extLst>
+              <a:ext uri="{FF2B5EF4-FFF2-40B4-BE49-F238E27FC236}">
+                <a16:creationId xmlns:a16="http://schemas.microsoft.com/office/drawing/2014/main" id="{9580D44D-D9EF-9EB6-3220-959D4758A5EB}"/>
+              </a:ext>
+            </a:extLst>
+          </p:cNvPr>
+          <p:cNvSpPr>
+            <a:spLocks noGrp="1"/>
+          </p:cNvSpPr>
+          <p:nvPr>
+            <p:ph type="title"/>
+          </p:nvPr>
+        </p:nvSpPr>
+        <p:spPr>
+          <a:xfrm>
+            <a:off x="411480" y="308611"/>
+            <a:ext cx="6903720" cy="685800"/>
+          </a:xfrm>
+        </p:spPr>
+        <p:txBody>
+          <a:bodyPr/>
+          <a:lstStyle/>
+          <a:p>
+            <a:r>
+              <a:rPr lang="en-US" dirty="0"/>
+              <a:t>What does </a:t>
+            </a:r>
+            <a:r>
+              <a:rPr lang="en-US" dirty="0" err="1"/>
+              <a:t>kobe</a:t>
+            </a:r>
+            <a:r>
+              <a:rPr lang="en-US" dirty="0"/>
+              <a:t> Bryant have to do with becoming a software developer?</a:t>
+            </a:r>
+          </a:p>
+        </p:txBody>
+      </p:sp>
+      <p:pic>
+        <p:nvPicPr>
+          <p:cNvPr id="6" name="Online Media 5" title="Kobe Bryant | Best Motivational Speech | New [HD]">
+            <a:hlinkClick r:id="" action="ppaction://media"/>
+            <a:extLst>
+              <a:ext uri="{FF2B5EF4-FFF2-40B4-BE49-F238E27FC236}">
+                <a16:creationId xmlns:a16="http://schemas.microsoft.com/office/drawing/2014/main" id="{6EA51B32-6B77-57A6-D9AA-EE3075D1A622}"/>
+              </a:ext>
+            </a:extLst>
+          </p:cNvPr>
+          <p:cNvPicPr>
+            <a:picLocks noRot="1" noChangeAspect="1"/>
+          </p:cNvPicPr>
+          <p:nvPr>
+            <a:videoFile r:link="rId1"/>
+          </p:nvPr>
+        </p:nvPicPr>
+        <p:blipFill>
+          <a:blip r:embed="rId4"/>
+          <a:stretch>
+            <a:fillRect/>
+          </a:stretch>
+        </p:blipFill>
+        <p:spPr>
+          <a:xfrm>
+            <a:off x="193288" y="1159004"/>
+            <a:ext cx="6506543" cy="3675885"/>
+          </a:xfrm>
+          <a:prstGeom prst="rect">
+            <a:avLst/>
+          </a:prstGeom>
+        </p:spPr>
+      </p:pic>
+      <p:sp>
+        <p:nvSpPr>
+          <p:cNvPr id="7" name="Google Shape;261;p46">
+            <a:extLst>
+              <a:ext uri="{FF2B5EF4-FFF2-40B4-BE49-F238E27FC236}">
+                <a16:creationId xmlns:a16="http://schemas.microsoft.com/office/drawing/2014/main" id="{46D3997A-6796-FDE3-5188-E92922B91419}"/>
+              </a:ext>
+            </a:extLst>
+          </p:cNvPr>
+          <p:cNvSpPr txBox="1">
+            <a:spLocks noGrp="1"/>
+          </p:cNvSpPr>
+          <p:nvPr>
+            <p:ph idx="1"/>
+          </p:nvPr>
+        </p:nvSpPr>
+        <p:spPr>
+          <a:xfrm>
+            <a:off x="6849450" y="1282446"/>
+            <a:ext cx="2172630" cy="3429000"/>
+          </a:xfrm>
+          <a:noFill/>
+          <a:ln>
+            <a:noFill/>
+          </a:ln>
+        </p:spPr>
+        <p:txBody>
+          <a:bodyPr spcFirstLastPara="1" wrap="square" lIns="91425" tIns="45700" rIns="91425" bIns="45700" anchor="t" anchorCtr="0">
+            <a:normAutofit/>
+          </a:bodyPr>
+          <a:lstStyle/>
+          <a:p>
+            <a:pPr lvl="0"/>
+            <a:r>
+              <a:rPr lang="en-US" dirty="0"/>
+              <a:t>We will show you the way… </a:t>
+            </a:r>
+          </a:p>
+          <a:p>
+            <a:pPr lvl="1"/>
+            <a:r>
+              <a:rPr lang="en-US" dirty="0"/>
+              <a:t>but you have to put in the work</a:t>
+            </a:r>
+          </a:p>
+          <a:p>
+            <a:pPr lvl="1"/>
+            <a:endParaRPr lang="en-US" dirty="0"/>
+          </a:p>
+          <a:p>
+            <a:pPr lvl="1"/>
+            <a:r>
+              <a:rPr lang="en-US" dirty="0"/>
+              <a:t>you have to help one another to truly succeed</a:t>
+            </a:r>
+          </a:p>
+        </p:txBody>
+      </p:sp>
+    </p:spTree>
+    <p:extLst>
+      <p:ext uri="{BB962C8B-B14F-4D97-AF65-F5344CB8AC3E}">
+        <p14:creationId xmlns:p14="http://schemas.microsoft.com/office/powerpoint/2010/main" val="2399285773"/>
+      </p:ext>
+    </p:extLst>
+  </p:cSld>
+  <p:clrMapOvr>
+    <a:masterClrMapping/>
+  </p:clrMapOvr>
+  <p:timing>
+    <p:tnLst>
+      <p:par>
+        <p:cTn id="1" dur="indefinite" restart="never" nodeType="tmRoot">
+          <p:childTnLst>
+            <p:seq concurrent="1" nextAc="seek">
+              <p:cTn id="2" dur="indefinite" nodeType="mainSeq">
+                <p:childTnLst>
+                  <p:par>
+                    <p:cTn id="3" fill="hold">
+                      <p:stCondLst>
+                        <p:cond delay="indefinite"/>
+                      </p:stCondLst>
+                      <p:childTnLst>
+                        <p:par>
+                          <p:cTn id="4" fill="hold">
+                            <p:stCondLst>
+                              <p:cond delay="0"/>
+                            </p:stCondLst>
+                            <p:childTnLst>
+                              <p:par>
+                                <p:cTn id="5" presetID="1" presetClass="mediacall" presetSubtype="0" fill="hold" nodeType="clickEffect">
+                                  <p:stCondLst>
+                                    <p:cond delay="0"/>
+                                  </p:stCondLst>
+                                  <p:childTnLst>
+                                    <p:cmd type="call" cmd="playFrom(0.0)">
+                                      <p:cBhvr>
+                                        <p:cTn id="6" dur="1" fill="hold"/>
+                                        <p:tgtEl>
+                                          <p:spTgt spid="6"/>
+                                        </p:tgtEl>
+                                      </p:cBhvr>
+                                    </p:cmd>
+                                  </p:childTnLst>
+                                </p:cTn>
+                              </p:par>
+                            </p:childTnLst>
+                          </p:cTn>
+                        </p:par>
+                      </p:childTnLst>
+                    </p:cTn>
+                  </p:par>
+                  <p:par>
+                    <p:cTn id="7" fill="hold">
+                      <p:stCondLst>
+                        <p:cond delay="indefinite"/>
+                      </p:stCondLst>
+                      <p:childTnLst>
+                        <p:par>
+                          <p:cTn id="8" fill="hold">
+                            <p:stCondLst>
+                              <p:cond delay="0"/>
+                            </p:stCondLst>
+                            <p:childTnLst>
+                              <p:par>
+                                <p:cTn id="9" presetID="1" presetClass="entr" presetSubtype="0" fill="hold" nodeType="clickEffect">
+                                  <p:stCondLst>
+                                    <p:cond delay="0"/>
+                                  </p:stCondLst>
+                                  <p:childTnLst>
+                                    <p:set>
+                                      <p:cBhvr>
+                                        <p:cTn id="10" dur="1" fill="hold">
+                                          <p:stCondLst>
+                                            <p:cond delay="0"/>
+                                          </p:stCondLst>
+                                        </p:cTn>
+                                        <p:tgtEl>
+                                          <p:spTgt spid="7">
+                                            <p:txEl>
+                                              <p:pRg st="0" end="0"/>
+                                            </p:txEl>
+                                          </p:spTgt>
+                                        </p:tgtEl>
+                                        <p:attrNameLst>
+                                          <p:attrName>style.visibility</p:attrName>
+                                        </p:attrNameLst>
+                                      </p:cBhvr>
+                                      <p:to>
+                                        <p:strVal val="visible"/>
+                                      </p:to>
+                                    </p:set>
+                                  </p:childTnLst>
+                                </p:cTn>
+                              </p:par>
+                            </p:childTnLst>
+                          </p:cTn>
+                        </p:par>
+                      </p:childTnLst>
+                    </p:cTn>
+                  </p:par>
+                  <p:par>
+                    <p:cTn id="11" fill="hold">
+                      <p:stCondLst>
+                        <p:cond delay="indefinite"/>
+                      </p:stCondLst>
+                      <p:childTnLst>
+                        <p:par>
+                          <p:cTn id="12" fill="hold">
+                            <p:stCondLst>
+                              <p:cond delay="0"/>
+                            </p:stCondLst>
+                            <p:childTnLst>
+                              <p:par>
+                                <p:cTn id="13" presetID="1" presetClass="entr" presetSubtype="0" fill="hold" nodeType="clickEffect">
+                                  <p:stCondLst>
+                                    <p:cond delay="0"/>
+                                  </p:stCondLst>
+                                  <p:childTnLst>
+                                    <p:set>
+                                      <p:cBhvr>
+                                        <p:cTn id="14" dur="1" fill="hold">
+                                          <p:stCondLst>
+                                            <p:cond delay="0"/>
+                                          </p:stCondLst>
+                                        </p:cTn>
+                                        <p:tgtEl>
+                                          <p:spTgt spid="7">
+                                            <p:txEl>
+                                              <p:pRg st="1" end="1"/>
+                                            </p:txEl>
+                                          </p:spTgt>
+                                        </p:tgtEl>
+                                        <p:attrNameLst>
+                                          <p:attrName>style.visibility</p:attrName>
+                                        </p:attrNameLst>
+                                      </p:cBhvr>
+                                      <p:to>
+                                        <p:strVal val="visible"/>
+                                      </p:to>
+                                    </p:set>
+                                  </p:childTnLst>
+                                </p:cTn>
+                              </p:par>
+                            </p:childTnLst>
+                          </p:cTn>
+                        </p:par>
+                      </p:childTnLst>
+                    </p:cTn>
+                  </p:par>
+                  <p:par>
+                    <p:cTn id="15" fill="hold">
+                      <p:stCondLst>
+                        <p:cond delay="indefinite"/>
+                      </p:stCondLst>
+                      <p:childTnLst>
+                        <p:par>
+                          <p:cTn id="16" fill="hold">
+                            <p:stCondLst>
+                              <p:cond delay="0"/>
+                            </p:stCondLst>
+                            <p:childTnLst>
+                              <p:par>
+                                <p:cTn id="17" presetID="1" presetClass="entr" presetSubtype="0" fill="hold" nodeType="clickEffect">
+                                  <p:stCondLst>
+                                    <p:cond delay="0"/>
+                                  </p:stCondLst>
+                                  <p:childTnLst>
+                                    <p:set>
+                                      <p:cBhvr>
+                                        <p:cTn id="18" dur="1" fill="hold">
+                                          <p:stCondLst>
+                                            <p:cond delay="0"/>
+                                          </p:stCondLst>
+                                        </p:cTn>
+                                        <p:tgtEl>
+                                          <p:spTgt spid="7">
+                                            <p:txEl>
+                                              <p:pRg st="3" end="3"/>
+                                            </p:txEl>
+                                          </p:spTgt>
+                                        </p:tgtEl>
+                                        <p:attrNameLst>
+                                          <p:attrName>style.visibility</p:attrName>
+                                        </p:attrNameLst>
+                                      </p:cBhvr>
+                                      <p:to>
+                                        <p:strVal val="visible"/>
+                                      </p:to>
+                                    </p:set>
+                                  </p:childTnLst>
+                                </p:cTn>
+                              </p:par>
+                            </p:childTnLst>
+                          </p:cTn>
+                        </p:par>
+                      </p:childTnLst>
+                    </p:cTn>
+                  </p:par>
+                </p:childTnLst>
+              </p:cTn>
+              <p:prevCondLst>
+                <p:cond evt="onPrev" delay="0">
+                  <p:tgtEl>
+                    <p:sldTgt/>
+                  </p:tgtEl>
+                </p:cond>
+              </p:prevCondLst>
+              <p:nextCondLst>
+                <p:cond evt="onNext" delay="0">
+                  <p:tgtEl>
+                    <p:sldTgt/>
+                  </p:tgtEl>
+                </p:cond>
+              </p:nextCondLst>
+            </p:seq>
+            <p:video>
+              <p:cMediaNode vol="80000">
+                <p:cTn id="19" fill="hold" display="0">
+                  <p:stCondLst>
+                    <p:cond delay="indefinite"/>
+                  </p:stCondLst>
+                </p:cTn>
+                <p:tgtEl>
+                  <p:spTgt spid="6"/>
+                </p:tgtEl>
+              </p:cMediaNode>
+            </p:video>
+            <p:seq concurrent="1" nextAc="seek">
+              <p:cTn id="20" restart="whenNotActive" fill="hold" evtFilter="cancelBubble" nodeType="interactiveSeq">
+                <p:stCondLst>
+                  <p:cond evt="onClick" delay="0">
+                    <p:tgtEl>
+                      <p:spTgt spid="6"/>
+                    </p:tgtEl>
+                  </p:cond>
+                </p:stCondLst>
+                <p:endSync evt="end" delay="0">
+                  <p:rtn val="all"/>
+                </p:endSync>
+                <p:childTnLst>
+                  <p:par>
+                    <p:cTn id="21" fill="hold">
+                      <p:stCondLst>
+                        <p:cond delay="0"/>
+                      </p:stCondLst>
+                      <p:childTnLst>
+                        <p:par>
+                          <p:cTn id="22" fill="hold">
+                            <p:stCondLst>
+                              <p:cond delay="0"/>
+                            </p:stCondLst>
+                            <p:childTnLst>
+                              <p:par>
+                                <p:cTn id="23" presetID="2" presetClass="mediacall" presetSubtype="0" fill="hold" nodeType="clickEffect">
+                                  <p:stCondLst>
+                                    <p:cond delay="0"/>
+                                  </p:stCondLst>
+                                  <p:childTnLst>
+                                    <p:cmd type="call" cmd="togglePause">
+                                      <p:cBhvr>
+                                        <p:cTn id="24" dur="1" fill="hold"/>
+                                        <p:tgtEl>
+                                          <p:spTgt spid="6"/>
+                                        </p:tgtEl>
+                                      </p:cBhvr>
+                                    </p:cmd>
+                                  </p:childTnLst>
+                                </p:cTn>
+                              </p:par>
+                            </p:childTnLst>
+                          </p:cTn>
+                        </p:par>
+                      </p:childTnLst>
+                    </p:cTn>
+                  </p:par>
+                </p:childTnLst>
+              </p:cTn>
+              <p:nextCondLst>
+                <p:cond evt="onClick" delay="0">
+                  <p:tgtEl>
+                    <p:spTgt spid="6"/>
+                  </p:tgtEl>
+                </p:cond>
+              </p:nextCondLst>
+            </p:seq>
+          </p:childTnLst>
+        </p:cTn>
+      </p:par>
+    </p:tnLst>
+  </p:timing>
+</p:sld>
+</file>
+
+<file path=ppt/slides/slide20.xml><?xml version="1.0" encoding="utf-8"?>
 <p:sld xmlns:a="http://schemas.openxmlformats.org/drawingml/2006/main" xmlns:r="http://schemas.openxmlformats.org/officeDocument/2006/relationships" xmlns:p="http://schemas.openxmlformats.org/presentationml/2006/main">
   <p:cSld>
     <p:spTree>
@@ -36258,457 +37217,7 @@
 </p:sld>
 </file>
 
-<file path=ppt/slides/slide2.xml><?xml version="1.0" encoding="utf-8"?>
-<p:sld xmlns:a="http://schemas.openxmlformats.org/drawingml/2006/main" xmlns:r="http://schemas.openxmlformats.org/officeDocument/2006/relationships" xmlns:p="http://schemas.openxmlformats.org/presentationml/2006/main">
-  <p:cSld>
-    <p:spTree>
-      <p:nvGrpSpPr>
-        <p:cNvPr id="1" name="Shape 259">
-          <a:extLst>
-            <a:ext uri="{FF2B5EF4-FFF2-40B4-BE49-F238E27FC236}">
-              <a16:creationId xmlns:a16="http://schemas.microsoft.com/office/drawing/2014/main" id="{341FB50C-5882-3994-477F-1ACB25D0968F}"/>
-            </a:ext>
-          </a:extLst>
-        </p:cNvPr>
-        <p:cNvGrpSpPr/>
-        <p:nvPr/>
-      </p:nvGrpSpPr>
-      <p:grpSpPr>
-        <a:xfrm>
-          <a:off x="0" y="0"/>
-          <a:ext cx="0" cy="0"/>
-          <a:chOff x="0" y="0"/>
-          <a:chExt cx="0" cy="0"/>
-        </a:xfrm>
-      </p:grpSpPr>
-      <p:sp>
-        <p:nvSpPr>
-          <p:cNvPr id="5" name="Title 4">
-            <a:extLst>
-              <a:ext uri="{FF2B5EF4-FFF2-40B4-BE49-F238E27FC236}">
-                <a16:creationId xmlns:a16="http://schemas.microsoft.com/office/drawing/2014/main" id="{9580D44D-D9EF-9EB6-3220-959D4758A5EB}"/>
-              </a:ext>
-            </a:extLst>
-          </p:cNvPr>
-          <p:cNvSpPr>
-            <a:spLocks noGrp="1"/>
-          </p:cNvSpPr>
-          <p:nvPr>
-            <p:ph type="title"/>
-          </p:nvPr>
-        </p:nvSpPr>
-        <p:spPr>
-          <a:xfrm>
-            <a:off x="411480" y="308611"/>
-            <a:ext cx="6903720" cy="685800"/>
-          </a:xfrm>
-        </p:spPr>
-        <p:txBody>
-          <a:bodyPr/>
-          <a:lstStyle/>
-          <a:p>
-            <a:r>
-              <a:rPr lang="en-US" dirty="0"/>
-              <a:t>What does </a:t>
-            </a:r>
-            <a:r>
-              <a:rPr lang="en-US" dirty="0" err="1"/>
-              <a:t>kobe</a:t>
-            </a:r>
-            <a:r>
-              <a:rPr lang="en-US" dirty="0"/>
-              <a:t> Bryant have to do with becoming a software developer?</a:t>
-            </a:r>
-          </a:p>
-        </p:txBody>
-      </p:sp>
-      <p:pic>
-        <p:nvPicPr>
-          <p:cNvPr id="6" name="Online Media 5" title="Kobe Bryant | Best Motivational Speech | New [HD]">
-            <a:hlinkClick r:id="" action="ppaction://media"/>
-            <a:extLst>
-              <a:ext uri="{FF2B5EF4-FFF2-40B4-BE49-F238E27FC236}">
-                <a16:creationId xmlns:a16="http://schemas.microsoft.com/office/drawing/2014/main" id="{6EA51B32-6B77-57A6-D9AA-EE3075D1A622}"/>
-              </a:ext>
-            </a:extLst>
-          </p:cNvPr>
-          <p:cNvPicPr>
-            <a:picLocks noRot="1" noChangeAspect="1"/>
-          </p:cNvPicPr>
-          <p:nvPr>
-            <a:videoFile r:link="rId1"/>
-          </p:nvPr>
-        </p:nvPicPr>
-        <p:blipFill>
-          <a:blip r:embed="rId4"/>
-          <a:stretch>
-            <a:fillRect/>
-          </a:stretch>
-        </p:blipFill>
-        <p:spPr>
-          <a:xfrm>
-            <a:off x="193288" y="1159004"/>
-            <a:ext cx="6506543" cy="3675885"/>
-          </a:xfrm>
-          <a:prstGeom prst="rect">
-            <a:avLst/>
-          </a:prstGeom>
-        </p:spPr>
-      </p:pic>
-      <p:sp>
-        <p:nvSpPr>
-          <p:cNvPr id="7" name="Google Shape;261;p46">
-            <a:extLst>
-              <a:ext uri="{FF2B5EF4-FFF2-40B4-BE49-F238E27FC236}">
-                <a16:creationId xmlns:a16="http://schemas.microsoft.com/office/drawing/2014/main" id="{46D3997A-6796-FDE3-5188-E92922B91419}"/>
-              </a:ext>
-            </a:extLst>
-          </p:cNvPr>
-          <p:cNvSpPr txBox="1">
-            <a:spLocks noGrp="1"/>
-          </p:cNvSpPr>
-          <p:nvPr>
-            <p:ph idx="1"/>
-          </p:nvPr>
-        </p:nvSpPr>
-        <p:spPr>
-          <a:xfrm>
-            <a:off x="6849450" y="1282446"/>
-            <a:ext cx="2172630" cy="3429000"/>
-          </a:xfrm>
-          <a:noFill/>
-          <a:ln>
-            <a:noFill/>
-          </a:ln>
-        </p:spPr>
-        <p:txBody>
-          <a:bodyPr spcFirstLastPara="1" wrap="square" lIns="91425" tIns="45700" rIns="91425" bIns="45700" anchor="t" anchorCtr="0">
-            <a:normAutofit/>
-          </a:bodyPr>
-          <a:lstStyle/>
-          <a:p>
-            <a:pPr lvl="0"/>
-            <a:r>
-              <a:rPr lang="en-US" dirty="0"/>
-              <a:t>We will show you the way… </a:t>
-            </a:r>
-          </a:p>
-          <a:p>
-            <a:pPr lvl="1"/>
-            <a:r>
-              <a:rPr lang="en-US" dirty="0"/>
-              <a:t>but you have to put in the work</a:t>
-            </a:r>
-          </a:p>
-          <a:p>
-            <a:pPr lvl="1"/>
-            <a:endParaRPr lang="en-US" dirty="0"/>
-          </a:p>
-          <a:p>
-            <a:pPr lvl="1"/>
-            <a:r>
-              <a:rPr lang="en-US" dirty="0"/>
-              <a:t>you have to help one another to truly succeed</a:t>
-            </a:r>
-          </a:p>
-        </p:txBody>
-      </p:sp>
-    </p:spTree>
-    <p:extLst>
-      <p:ext uri="{BB962C8B-B14F-4D97-AF65-F5344CB8AC3E}">
-        <p14:creationId xmlns:p14="http://schemas.microsoft.com/office/powerpoint/2010/main" val="2399285773"/>
-      </p:ext>
-    </p:extLst>
-  </p:cSld>
-  <p:clrMapOvr>
-    <a:masterClrMapping/>
-  </p:clrMapOvr>
-  <p:timing>
-    <p:tnLst>
-      <p:par>
-        <p:cTn id="1" dur="indefinite" restart="never" nodeType="tmRoot">
-          <p:childTnLst>
-            <p:seq concurrent="1" nextAc="seek">
-              <p:cTn id="2" dur="indefinite" nodeType="mainSeq">
-                <p:childTnLst>
-                  <p:par>
-                    <p:cTn id="3" fill="hold">
-                      <p:stCondLst>
-                        <p:cond delay="indefinite"/>
-                      </p:stCondLst>
-                      <p:childTnLst>
-                        <p:par>
-                          <p:cTn id="4" fill="hold">
-                            <p:stCondLst>
-                              <p:cond delay="0"/>
-                            </p:stCondLst>
-                            <p:childTnLst>
-                              <p:par>
-                                <p:cTn id="5" presetID="1" presetClass="mediacall" presetSubtype="0" fill="hold" nodeType="clickEffect">
-                                  <p:stCondLst>
-                                    <p:cond delay="0"/>
-                                  </p:stCondLst>
-                                  <p:childTnLst>
-                                    <p:cmd type="call" cmd="playFrom(0.0)">
-                                      <p:cBhvr>
-                                        <p:cTn id="6" dur="1" fill="hold"/>
-                                        <p:tgtEl>
-                                          <p:spTgt spid="6"/>
-                                        </p:tgtEl>
-                                      </p:cBhvr>
-                                    </p:cmd>
-                                  </p:childTnLst>
-                                </p:cTn>
-                              </p:par>
-                            </p:childTnLst>
-                          </p:cTn>
-                        </p:par>
-                      </p:childTnLst>
-                    </p:cTn>
-                  </p:par>
-                  <p:par>
-                    <p:cTn id="7" fill="hold">
-                      <p:stCondLst>
-                        <p:cond delay="indefinite"/>
-                      </p:stCondLst>
-                      <p:childTnLst>
-                        <p:par>
-                          <p:cTn id="8" fill="hold">
-                            <p:stCondLst>
-                              <p:cond delay="0"/>
-                            </p:stCondLst>
-                            <p:childTnLst>
-                              <p:par>
-                                <p:cTn id="9" presetID="1" presetClass="entr" presetSubtype="0" fill="hold" nodeType="clickEffect">
-                                  <p:stCondLst>
-                                    <p:cond delay="0"/>
-                                  </p:stCondLst>
-                                  <p:childTnLst>
-                                    <p:set>
-                                      <p:cBhvr>
-                                        <p:cTn id="10" dur="1" fill="hold">
-                                          <p:stCondLst>
-                                            <p:cond delay="0"/>
-                                          </p:stCondLst>
-                                        </p:cTn>
-                                        <p:tgtEl>
-                                          <p:spTgt spid="7">
-                                            <p:txEl>
-                                              <p:pRg st="0" end="0"/>
-                                            </p:txEl>
-                                          </p:spTgt>
-                                        </p:tgtEl>
-                                        <p:attrNameLst>
-                                          <p:attrName>style.visibility</p:attrName>
-                                        </p:attrNameLst>
-                                      </p:cBhvr>
-                                      <p:to>
-                                        <p:strVal val="visible"/>
-                                      </p:to>
-                                    </p:set>
-                                  </p:childTnLst>
-                                </p:cTn>
-                              </p:par>
-                            </p:childTnLst>
-                          </p:cTn>
-                        </p:par>
-                      </p:childTnLst>
-                    </p:cTn>
-                  </p:par>
-                  <p:par>
-                    <p:cTn id="11" fill="hold">
-                      <p:stCondLst>
-                        <p:cond delay="indefinite"/>
-                      </p:stCondLst>
-                      <p:childTnLst>
-                        <p:par>
-                          <p:cTn id="12" fill="hold">
-                            <p:stCondLst>
-                              <p:cond delay="0"/>
-                            </p:stCondLst>
-                            <p:childTnLst>
-                              <p:par>
-                                <p:cTn id="13" presetID="1" presetClass="entr" presetSubtype="0" fill="hold" nodeType="clickEffect">
-                                  <p:stCondLst>
-                                    <p:cond delay="0"/>
-                                  </p:stCondLst>
-                                  <p:childTnLst>
-                                    <p:set>
-                                      <p:cBhvr>
-                                        <p:cTn id="14" dur="1" fill="hold">
-                                          <p:stCondLst>
-                                            <p:cond delay="0"/>
-                                          </p:stCondLst>
-                                        </p:cTn>
-                                        <p:tgtEl>
-                                          <p:spTgt spid="7">
-                                            <p:txEl>
-                                              <p:pRg st="1" end="1"/>
-                                            </p:txEl>
-                                          </p:spTgt>
-                                        </p:tgtEl>
-                                        <p:attrNameLst>
-                                          <p:attrName>style.visibility</p:attrName>
-                                        </p:attrNameLst>
-                                      </p:cBhvr>
-                                      <p:to>
-                                        <p:strVal val="visible"/>
-                                      </p:to>
-                                    </p:set>
-                                  </p:childTnLst>
-                                </p:cTn>
-                              </p:par>
-                            </p:childTnLst>
-                          </p:cTn>
-                        </p:par>
-                      </p:childTnLst>
-                    </p:cTn>
-                  </p:par>
-                  <p:par>
-                    <p:cTn id="15" fill="hold">
-                      <p:stCondLst>
-                        <p:cond delay="indefinite"/>
-                      </p:stCondLst>
-                      <p:childTnLst>
-                        <p:par>
-                          <p:cTn id="16" fill="hold">
-                            <p:stCondLst>
-                              <p:cond delay="0"/>
-                            </p:stCondLst>
-                            <p:childTnLst>
-                              <p:par>
-                                <p:cTn id="17" presetID="1" presetClass="entr" presetSubtype="0" fill="hold" nodeType="clickEffect">
-                                  <p:stCondLst>
-                                    <p:cond delay="0"/>
-                                  </p:stCondLst>
-                                  <p:childTnLst>
-                                    <p:set>
-                                      <p:cBhvr>
-                                        <p:cTn id="18" dur="1" fill="hold">
-                                          <p:stCondLst>
-                                            <p:cond delay="0"/>
-                                          </p:stCondLst>
-                                        </p:cTn>
-                                        <p:tgtEl>
-                                          <p:spTgt spid="7">
-                                            <p:txEl>
-                                              <p:pRg st="3" end="3"/>
-                                            </p:txEl>
-                                          </p:spTgt>
-                                        </p:tgtEl>
-                                        <p:attrNameLst>
-                                          <p:attrName>style.visibility</p:attrName>
-                                        </p:attrNameLst>
-                                      </p:cBhvr>
-                                      <p:to>
-                                        <p:strVal val="visible"/>
-                                      </p:to>
-                                    </p:set>
-                                  </p:childTnLst>
-                                </p:cTn>
-                              </p:par>
-                            </p:childTnLst>
-                          </p:cTn>
-                        </p:par>
-                      </p:childTnLst>
-                    </p:cTn>
-                  </p:par>
-                </p:childTnLst>
-              </p:cTn>
-              <p:prevCondLst>
-                <p:cond evt="onPrev" delay="0">
-                  <p:tgtEl>
-                    <p:sldTgt/>
-                  </p:tgtEl>
-                </p:cond>
-              </p:prevCondLst>
-              <p:nextCondLst>
-                <p:cond evt="onNext" delay="0">
-                  <p:tgtEl>
-                    <p:sldTgt/>
-                  </p:tgtEl>
-                </p:cond>
-              </p:nextCondLst>
-            </p:seq>
-            <p:video>
-              <p:cMediaNode vol="80000">
-                <p:cTn id="19" fill="hold" display="0">
-                  <p:stCondLst>
-                    <p:cond delay="indefinite"/>
-                  </p:stCondLst>
-                </p:cTn>
-                <p:tgtEl>
-                  <p:spTgt spid="6"/>
-                </p:tgtEl>
-              </p:cMediaNode>
-            </p:video>
-            <p:seq concurrent="1" nextAc="seek">
-              <p:cTn id="20" restart="whenNotActive" fill="hold" evtFilter="cancelBubble" nodeType="interactiveSeq">
-                <p:stCondLst>
-                  <p:cond evt="onClick" delay="0">
-                    <p:tgtEl>
-                      <p:spTgt spid="6"/>
-                    </p:tgtEl>
-                  </p:cond>
-                </p:stCondLst>
-                <p:endSync evt="end" delay="0">
-                  <p:rtn val="all"/>
-                </p:endSync>
-                <p:childTnLst>
-                  <p:par>
-                    <p:cTn id="21" fill="hold">
-                      <p:stCondLst>
-                        <p:cond delay="0"/>
-                      </p:stCondLst>
-                      <p:childTnLst>
-                        <p:par>
-                          <p:cTn id="22" fill="hold">
-                            <p:stCondLst>
-                              <p:cond delay="0"/>
-                            </p:stCondLst>
-                            <p:childTnLst>
-                              <p:par>
-                                <p:cTn id="23" presetID="2" presetClass="mediacall" presetSubtype="0" fill="hold" nodeType="clickEffect">
-                                  <p:stCondLst>
-                                    <p:cond delay="0"/>
-                                  </p:stCondLst>
-                                  <p:childTnLst>
-                                    <p:cmd type="call" cmd="togglePause">
-                                      <p:cBhvr>
-                                        <p:cTn id="24" dur="1" fill="hold"/>
-                                        <p:tgtEl>
-                                          <p:spTgt spid="6"/>
-                                        </p:tgtEl>
-                                      </p:cBhvr>
-                                    </p:cmd>
-                                  </p:childTnLst>
-                                </p:cTn>
-                              </p:par>
-                            </p:childTnLst>
-                          </p:cTn>
-                        </p:par>
-                      </p:childTnLst>
-                    </p:cTn>
-                  </p:par>
-                </p:childTnLst>
-              </p:cTn>
-              <p:nextCondLst>
-                <p:cond evt="onClick" delay="0">
-                  <p:tgtEl>
-                    <p:spTgt spid="6"/>
-                  </p:tgtEl>
-                </p:cond>
-              </p:nextCondLst>
-            </p:seq>
-          </p:childTnLst>
-        </p:cTn>
-      </p:par>
-    </p:tnLst>
-  </p:timing>
-</p:sld>
-</file>
-
-<file path=ppt/slides/slide20.xml><?xml version="1.0" encoding="utf-8"?>
+<file path=ppt/slides/slide21.xml><?xml version="1.0" encoding="utf-8"?>
 <p:sld xmlns:a="http://schemas.openxmlformats.org/drawingml/2006/main" xmlns:r="http://schemas.openxmlformats.org/officeDocument/2006/relationships" xmlns:p="http://schemas.openxmlformats.org/presentationml/2006/main">
   <p:cSld>
     <p:spTree>
@@ -37430,7 +37939,7 @@
 </p:sld>
 </file>
 
-<file path=ppt/slides/slide21.xml><?xml version="1.0" encoding="utf-8"?>
+<file path=ppt/slides/slide22.xml><?xml version="1.0" encoding="utf-8"?>
 <p:sld xmlns:a="http://schemas.openxmlformats.org/drawingml/2006/main" xmlns:r="http://schemas.openxmlformats.org/officeDocument/2006/relationships" xmlns:p="http://schemas.openxmlformats.org/presentationml/2006/main">
   <p:cSld>
     <p:spTree>
@@ -37816,7 +38325,7 @@
 </p:sld>
 </file>
 
-<file path=ppt/slides/slide22.xml><?xml version="1.0" encoding="utf-8"?>
+<file path=ppt/slides/slide23.xml><?xml version="1.0" encoding="utf-8"?>
 <p:sld xmlns:a="http://schemas.openxmlformats.org/drawingml/2006/main" xmlns:r="http://schemas.openxmlformats.org/officeDocument/2006/relationships" xmlns:p="http://schemas.openxmlformats.org/presentationml/2006/main">
   <p:cSld>
     <p:spTree>
@@ -37978,7 +38487,7 @@
 </p:sld>
 </file>
 
-<file path=ppt/slides/slide23.xml><?xml version="1.0" encoding="utf-8"?>
+<file path=ppt/slides/slide24.xml><?xml version="1.0" encoding="utf-8"?>
 <p:sld xmlns:a="http://schemas.openxmlformats.org/drawingml/2006/main" xmlns:r="http://schemas.openxmlformats.org/officeDocument/2006/relationships" xmlns:p="http://schemas.openxmlformats.org/presentationml/2006/main">
   <p:cSld>
     <p:spTree>
@@ -38038,7 +38547,7 @@
 </p:sld>
 </file>
 
-<file path=ppt/slides/slide24.xml><?xml version="1.0" encoding="utf-8"?>
+<file path=ppt/slides/slide25.xml><?xml version="1.0" encoding="utf-8"?>
 <p:sld xmlns:a="http://schemas.openxmlformats.org/drawingml/2006/main" xmlns:r="http://schemas.openxmlformats.org/officeDocument/2006/relationships" xmlns:p="http://schemas.openxmlformats.org/presentationml/2006/main">
   <p:cSld>
     <p:spTree>
@@ -38109,7 +38618,7 @@
 </p:sld>
 </file>
 
-<file path=ppt/slides/slide25.xml><?xml version="1.0" encoding="utf-8"?>
+<file path=ppt/slides/slide26.xml><?xml version="1.0" encoding="utf-8"?>
 <p:sld xmlns:a="http://schemas.openxmlformats.org/drawingml/2006/main" xmlns:r="http://schemas.openxmlformats.org/officeDocument/2006/relationships" xmlns:p="http://schemas.openxmlformats.org/presentationml/2006/main">
   <p:cSld>
     <p:spTree>
@@ -38798,7 +39307,7 @@
 </p:sld>
 </file>
 
-<file path=ppt/slides/slide26.xml><?xml version="1.0" encoding="utf-8"?>
+<file path=ppt/slides/slide27.xml><?xml version="1.0" encoding="utf-8"?>
 <p:sld xmlns:a="http://schemas.openxmlformats.org/drawingml/2006/main" xmlns:r="http://schemas.openxmlformats.org/officeDocument/2006/relationships" xmlns:p="http://schemas.openxmlformats.org/presentationml/2006/main">
   <p:cSld>
     <p:spTree>
@@ -39056,7 +39565,7 @@
 </p:sld>
 </file>
 
-<file path=ppt/slides/slide27.xml><?xml version="1.0" encoding="utf-8"?>
+<file path=ppt/slides/slide28.xml><?xml version="1.0" encoding="utf-8"?>
 <p:sld xmlns:a="http://schemas.openxmlformats.org/drawingml/2006/main" xmlns:r="http://schemas.openxmlformats.org/officeDocument/2006/relationships" xmlns:p="http://schemas.openxmlformats.org/presentationml/2006/main">
   <p:cSld>
     <p:spTree>
@@ -39198,7 +39707,7 @@
           <a:p>
             <a:fld id="{334F72C3-CDF3-44A8-B602-1649B1728485}" type="datetime3">
               <a:rPr lang="en-US" smtClean="0"/>
-              <a:t>9 July 2026</a:t>
+              <a:t>10 July 2026</a:t>
             </a:fld>
             <a:endParaRPr lang="en-US"/>
           </a:p>
@@ -39228,7 +39737,7 @@
             <a:fld id="{64E5BE4B-2FBF-4174-9E62-85FAD1CB43A6}" type="slidenum">
               <a:rPr lang="en-US" smtClean="0"/>
               <a:pPr/>
-              <a:t>27</a:t>
+              <a:t>28</a:t>
             </a:fld>
             <a:endParaRPr lang="en-US"/>
           </a:p>
@@ -39477,7 +39986,7 @@
 </p:sld>
 </file>
 
-<file path=ppt/slides/slide28.xml><?xml version="1.0" encoding="utf-8"?>
+<file path=ppt/slides/slide29.xml><?xml version="1.0" encoding="utf-8"?>
 <p:sld xmlns:a="http://schemas.openxmlformats.org/drawingml/2006/main" xmlns:r="http://schemas.openxmlformats.org/officeDocument/2006/relationships" xmlns:p="http://schemas.openxmlformats.org/presentationml/2006/main">
   <p:cSld>
     <p:spTree>
@@ -39523,7 +40032,7 @@
           <a:p>
             <a:fld id="{334F72C3-CDF3-44A8-B602-1649B1728485}" type="datetime3">
               <a:rPr lang="en-US" smtClean="0"/>
-              <a:t>9 July 2026</a:t>
+              <a:t>10 July 2026</a:t>
             </a:fld>
             <a:endParaRPr lang="en-US"/>
           </a:p>
@@ -39553,7 +40062,7 @@
             <a:fld id="{64E5BE4B-2FBF-4174-9E62-85FAD1CB43A6}" type="slidenum">
               <a:rPr lang="en-US" smtClean="0"/>
               <a:pPr/>
-              <a:t>28</a:t>
+              <a:t>29</a:t>
             </a:fld>
             <a:endParaRPr lang="en-US"/>
           </a:p>
@@ -39699,455 +40208,6 @@
   <p:clrMapOvr>
     <a:masterClrMapping/>
   </p:clrMapOvr>
-</p:sld>
-</file>
-
-<file path=ppt/slides/slide29.xml><?xml version="1.0" encoding="utf-8"?>
-<p:sld xmlns:a="http://schemas.openxmlformats.org/drawingml/2006/main" xmlns:r="http://schemas.openxmlformats.org/officeDocument/2006/relationships" xmlns:p="http://schemas.openxmlformats.org/presentationml/2006/main">
-  <p:cSld>
-    <p:spTree>
-      <p:nvGrpSpPr>
-        <p:cNvPr id="1" name="">
-          <a:extLst>
-            <a:ext uri="{FF2B5EF4-FFF2-40B4-BE49-F238E27FC236}">
-              <a16:creationId xmlns:a16="http://schemas.microsoft.com/office/drawing/2014/main" id="{061B13E0-3E87-00EB-FAED-C1660C725917}"/>
-            </a:ext>
-          </a:extLst>
-        </p:cNvPr>
-        <p:cNvGrpSpPr/>
-        <p:nvPr/>
-      </p:nvGrpSpPr>
-      <p:grpSpPr>
-        <a:xfrm>
-          <a:off x="0" y="0"/>
-          <a:ext cx="0" cy="0"/>
-          <a:chOff x="0" y="0"/>
-          <a:chExt cx="0" cy="0"/>
-        </a:xfrm>
-      </p:grpSpPr>
-      <p:sp>
-        <p:nvSpPr>
-          <p:cNvPr id="5" name="Date Placeholder 4">
-            <a:extLst>
-              <a:ext uri="{FF2B5EF4-FFF2-40B4-BE49-F238E27FC236}">
-                <a16:creationId xmlns:a16="http://schemas.microsoft.com/office/drawing/2014/main" id="{6177AF59-EA2D-41F4-9542-F2556090BB96}"/>
-              </a:ext>
-            </a:extLst>
-          </p:cNvPr>
-          <p:cNvSpPr>
-            <a:spLocks noGrp="1"/>
-          </p:cNvSpPr>
-          <p:nvPr>
-            <p:ph type="dt" sz="half" idx="10"/>
-          </p:nvPr>
-        </p:nvSpPr>
-        <p:spPr/>
-        <p:txBody>
-          <a:bodyPr/>
-          <a:lstStyle/>
-          <a:p>
-            <a:fld id="{334F72C3-CDF3-44A8-B602-1649B1728485}" type="datetime3">
-              <a:rPr lang="en-US" smtClean="0"/>
-              <a:t>9 July 2026</a:t>
-            </a:fld>
-            <a:endParaRPr lang="en-US"/>
-          </a:p>
-        </p:txBody>
-      </p:sp>
-      <p:sp>
-        <p:nvSpPr>
-          <p:cNvPr id="6" name="Slide Number Placeholder 5">
-            <a:extLst>
-              <a:ext uri="{FF2B5EF4-FFF2-40B4-BE49-F238E27FC236}">
-                <a16:creationId xmlns:a16="http://schemas.microsoft.com/office/drawing/2014/main" id="{F4C119CF-0F77-60E2-B8F0-81835FEAD513}"/>
-              </a:ext>
-            </a:extLst>
-          </p:cNvPr>
-          <p:cNvSpPr>
-            <a:spLocks noGrp="1"/>
-          </p:cNvSpPr>
-          <p:nvPr>
-            <p:ph type="sldNum" sz="quarter" idx="11"/>
-          </p:nvPr>
-        </p:nvSpPr>
-        <p:spPr/>
-        <p:txBody>
-          <a:bodyPr/>
-          <a:lstStyle/>
-          <a:p>
-            <a:fld id="{64E5BE4B-2FBF-4174-9E62-85FAD1CB43A6}" type="slidenum">
-              <a:rPr lang="en-US" smtClean="0"/>
-              <a:pPr/>
-              <a:t>29</a:t>
-            </a:fld>
-            <a:endParaRPr lang="en-US"/>
-          </a:p>
-        </p:txBody>
-      </p:sp>
-      <p:sp>
-        <p:nvSpPr>
-          <p:cNvPr id="11" name="Content Placeholder 10">
-            <a:extLst>
-              <a:ext uri="{FF2B5EF4-FFF2-40B4-BE49-F238E27FC236}">
-                <a16:creationId xmlns:a16="http://schemas.microsoft.com/office/drawing/2014/main" id="{028668B5-9C66-E6D4-D5EA-B52A0AAC5AA4}"/>
-              </a:ext>
-            </a:extLst>
-          </p:cNvPr>
-          <p:cNvSpPr>
-            <a:spLocks noGrp="1"/>
-          </p:cNvSpPr>
-          <p:nvPr>
-            <p:ph sz="half" idx="1"/>
-          </p:nvPr>
-        </p:nvSpPr>
-        <p:spPr>
-          <a:xfrm>
-            <a:off x="411478" y="1200150"/>
-            <a:ext cx="8219566" cy="3429000"/>
-          </a:xfrm>
-        </p:spPr>
-        <p:txBody>
-          <a:bodyPr/>
-          <a:lstStyle/>
-          <a:p>
-            <a:r>
-              <a:rPr lang="en-US" sz="1800" dirty="0"/>
-              <a:t>What datatypes can it accept?</a:t>
-            </a:r>
-          </a:p>
-          <a:p>
-            <a:endParaRPr lang="en-US" sz="1800" dirty="0"/>
-          </a:p>
-          <a:p>
-            <a:endParaRPr lang="en-US" sz="1800" dirty="0"/>
-          </a:p>
-          <a:p>
-            <a:endParaRPr lang="en-US" sz="1800" dirty="0"/>
-          </a:p>
-          <a:p>
-            <a:endParaRPr lang="en-US" sz="1800" dirty="0"/>
-          </a:p>
-          <a:p>
-            <a:endParaRPr lang="en-US" sz="1800" dirty="0"/>
-          </a:p>
-          <a:p>
-            <a:endParaRPr lang="en-US" sz="1800" dirty="0"/>
-          </a:p>
-          <a:p>
-            <a:r>
-              <a:rPr lang="en-US" sz="1800" dirty="0"/>
-              <a:t>What do you notice about the output on the right?</a:t>
-            </a:r>
-          </a:p>
-          <a:p>
-            <a:endParaRPr lang="en-US" sz="1800" dirty="0"/>
-          </a:p>
-          <a:p>
-            <a:endParaRPr lang="en-US" sz="1800" dirty="0"/>
-          </a:p>
-        </p:txBody>
-      </p:sp>
-      <p:sp>
-        <p:nvSpPr>
-          <p:cNvPr id="3" name="Google Shape;319;p55">
-            <a:extLst>
-              <a:ext uri="{FF2B5EF4-FFF2-40B4-BE49-F238E27FC236}">
-                <a16:creationId xmlns:a16="http://schemas.microsoft.com/office/drawing/2014/main" id="{D691970B-10BB-3724-A871-F43E1C6BBA17}"/>
-              </a:ext>
-            </a:extLst>
-          </p:cNvPr>
-          <p:cNvSpPr txBox="1">
-            <a:spLocks/>
-          </p:cNvSpPr>
-          <p:nvPr/>
-        </p:nvSpPr>
-        <p:spPr>
-          <a:xfrm>
-            <a:off x="288816" y="408972"/>
-            <a:ext cx="6173470" cy="685800"/>
-          </a:xfrm>
-          <a:prstGeom prst="rect">
-            <a:avLst/>
-          </a:prstGeom>
-          <a:noFill/>
-          <a:ln>
-            <a:noFill/>
-          </a:ln>
-        </p:spPr>
-        <p:txBody>
-          <a:bodyPr spcFirstLastPara="1" vert="horz" wrap="square" lIns="91425" tIns="45700" rIns="91425" bIns="45700" rtlCol="0" anchor="ctr" anchorCtr="0">
-            <a:normAutofit lnSpcReduction="10000"/>
-          </a:bodyPr>
-          <a:lstStyle>
-            <a:lvl1pPr algn="l" defTabSz="685800" rtl="0" eaLnBrk="1" latinLnBrk="0" hangingPunct="1">
-              <a:lnSpc>
-                <a:spcPct val="90000"/>
-              </a:lnSpc>
-              <a:spcBef>
-                <a:spcPct val="0"/>
-              </a:spcBef>
-              <a:buNone/>
-              <a:defRPr sz="2400" kern="1200" cap="all" baseline="0">
-                <a:solidFill>
-                  <a:schemeClr val="tx1"/>
-                </a:solidFill>
-                <a:latin typeface="+mj-lt"/>
-                <a:ea typeface="+mj-ea"/>
-                <a:cs typeface="+mj-cs"/>
-              </a:defRPr>
-            </a:lvl1pPr>
-          </a:lstStyle>
-          <a:p>
-            <a:pPr>
-              <a:buClrTx/>
-              <a:buFontTx/>
-            </a:pPr>
-            <a:r>
-              <a:rPr lang="en-US" dirty="0"/>
-              <a:t>MORE INFORMATION ABOU THE PRINT FUNCTION</a:t>
-            </a:r>
-          </a:p>
-        </p:txBody>
-      </p:sp>
-      <p:pic>
-        <p:nvPicPr>
-          <p:cNvPr id="4" name="Picture 3">
-            <a:extLst>
-              <a:ext uri="{FF2B5EF4-FFF2-40B4-BE49-F238E27FC236}">
-                <a16:creationId xmlns:a16="http://schemas.microsoft.com/office/drawing/2014/main" id="{A80242B1-EC70-BB1C-21A7-77FF11664436}"/>
-              </a:ext>
-            </a:extLst>
-          </p:cNvPr>
-          <p:cNvPicPr>
-            <a:picLocks noChangeAspect="1"/>
-          </p:cNvPicPr>
-          <p:nvPr/>
-        </p:nvPicPr>
-        <p:blipFill>
-          <a:blip r:embed="rId2"/>
-          <a:stretch>
-            <a:fillRect/>
-          </a:stretch>
-        </p:blipFill>
-        <p:spPr>
-          <a:xfrm>
-            <a:off x="1191396" y="1947775"/>
-            <a:ext cx="2600688" cy="1247949"/>
-          </a:xfrm>
-          <a:prstGeom prst="rect">
-            <a:avLst/>
-          </a:prstGeom>
-        </p:spPr>
-      </p:pic>
-      <p:pic>
-        <p:nvPicPr>
-          <p:cNvPr id="8" name="Picture 7">
-            <a:extLst>
-              <a:ext uri="{FF2B5EF4-FFF2-40B4-BE49-F238E27FC236}">
-                <a16:creationId xmlns:a16="http://schemas.microsoft.com/office/drawing/2014/main" id="{62D308B4-278C-41B1-7565-C6C0C20A65D6}"/>
-              </a:ext>
-            </a:extLst>
-          </p:cNvPr>
-          <p:cNvPicPr>
-            <a:picLocks noChangeAspect="1"/>
-          </p:cNvPicPr>
-          <p:nvPr/>
-        </p:nvPicPr>
-        <p:blipFill>
-          <a:blip r:embed="rId3"/>
-          <a:stretch>
-            <a:fillRect/>
-          </a:stretch>
-        </p:blipFill>
-        <p:spPr>
-          <a:xfrm>
-            <a:off x="5649510" y="1985879"/>
-            <a:ext cx="1124107" cy="1171739"/>
-          </a:xfrm>
-          <a:prstGeom prst="rect">
-            <a:avLst/>
-          </a:prstGeom>
-        </p:spPr>
-      </p:pic>
-    </p:spTree>
-    <p:extLst>
-      <p:ext uri="{BB962C8B-B14F-4D97-AF65-F5344CB8AC3E}">
-        <p14:creationId xmlns:p14="http://schemas.microsoft.com/office/powerpoint/2010/main" val="2564714597"/>
-      </p:ext>
-    </p:extLst>
-  </p:cSld>
-  <p:clrMapOvr>
-    <a:masterClrMapping/>
-  </p:clrMapOvr>
-  <p:timing>
-    <p:tnLst>
-      <p:par>
-        <p:cTn id="1" dur="indefinite" restart="never" nodeType="tmRoot">
-          <p:childTnLst>
-            <p:seq concurrent="1" nextAc="seek">
-              <p:cTn id="2" dur="indefinite" nodeType="mainSeq">
-                <p:childTnLst>
-                  <p:par>
-                    <p:cTn id="3" fill="hold">
-                      <p:stCondLst>
-                        <p:cond delay="indefinite"/>
-                      </p:stCondLst>
-                      <p:childTnLst>
-                        <p:par>
-                          <p:cTn id="4" fill="hold">
-                            <p:stCondLst>
-                              <p:cond delay="0"/>
-                            </p:stCondLst>
-                            <p:childTnLst>
-                              <p:par>
-                                <p:cTn id="5" presetID="1" presetClass="entr" presetSubtype="0" fill="hold" nodeType="clickEffect">
-                                  <p:stCondLst>
-                                    <p:cond delay="0"/>
-                                  </p:stCondLst>
-                                  <p:childTnLst>
-                                    <p:set>
-                                      <p:cBhvr>
-                                        <p:cTn id="6" dur="1" fill="hold">
-                                          <p:stCondLst>
-                                            <p:cond delay="0"/>
-                                          </p:stCondLst>
-                                        </p:cTn>
-                                        <p:tgtEl>
-                                          <p:spTgt spid="4"/>
-                                        </p:tgtEl>
-                                        <p:attrNameLst>
-                                          <p:attrName>style.visibility</p:attrName>
-                                        </p:attrNameLst>
-                                      </p:cBhvr>
-                                      <p:to>
-                                        <p:strVal val="visible"/>
-                                      </p:to>
-                                    </p:set>
-                                  </p:childTnLst>
-                                </p:cTn>
-                              </p:par>
-                            </p:childTnLst>
-                          </p:cTn>
-                        </p:par>
-                      </p:childTnLst>
-                    </p:cTn>
-                  </p:par>
-                  <p:par>
-                    <p:cTn id="7" fill="hold">
-                      <p:stCondLst>
-                        <p:cond delay="indefinite"/>
-                      </p:stCondLst>
-                      <p:childTnLst>
-                        <p:par>
-                          <p:cTn id="8" fill="hold">
-                            <p:stCondLst>
-                              <p:cond delay="0"/>
-                            </p:stCondLst>
-                            <p:childTnLst>
-                              <p:par>
-                                <p:cTn id="9" presetID="1" presetClass="entr" presetSubtype="0" fill="hold" nodeType="clickEffect">
-                                  <p:stCondLst>
-                                    <p:cond delay="0"/>
-                                  </p:stCondLst>
-                                  <p:childTnLst>
-                                    <p:set>
-                                      <p:cBhvr>
-                                        <p:cTn id="10" dur="1" fill="hold">
-                                          <p:stCondLst>
-                                            <p:cond delay="0"/>
-                                          </p:stCondLst>
-                                        </p:cTn>
-                                        <p:tgtEl>
-                                          <p:spTgt spid="8"/>
-                                        </p:tgtEl>
-                                        <p:attrNameLst>
-                                          <p:attrName>style.visibility</p:attrName>
-                                        </p:attrNameLst>
-                                      </p:cBhvr>
-                                      <p:to>
-                                        <p:strVal val="visible"/>
-                                      </p:to>
-                                    </p:set>
-                                  </p:childTnLst>
-                                </p:cTn>
-                              </p:par>
-                            </p:childTnLst>
-                          </p:cTn>
-                        </p:par>
-                      </p:childTnLst>
-                    </p:cTn>
-                  </p:par>
-                  <p:par>
-                    <p:cTn id="11" fill="hold">
-                      <p:stCondLst>
-                        <p:cond delay="indefinite"/>
-                      </p:stCondLst>
-                      <p:childTnLst>
-                        <p:par>
-                          <p:cTn id="12" fill="hold">
-                            <p:stCondLst>
-                              <p:cond delay="0"/>
-                            </p:stCondLst>
-                            <p:childTnLst>
-                              <p:par>
-                                <p:cTn id="13" presetID="1" presetClass="entr" presetSubtype="0" fill="hold" nodeType="clickEffect">
-                                  <p:stCondLst>
-                                    <p:cond delay="0"/>
-                                  </p:stCondLst>
-                                  <p:childTnLst>
-                                    <p:set>
-                                      <p:cBhvr>
-                                        <p:cTn id="14" dur="1" fill="hold">
-                                          <p:stCondLst>
-                                            <p:cond delay="0"/>
-                                          </p:stCondLst>
-                                        </p:cTn>
-                                        <p:tgtEl>
-                                          <p:spTgt spid="11">
-                                            <p:txEl>
-                                              <p:pRg st="7" end="7"/>
-                                            </p:txEl>
-                                          </p:spTgt>
-                                        </p:tgtEl>
-                                        <p:attrNameLst>
-                                          <p:attrName>style.visibility</p:attrName>
-                                        </p:attrNameLst>
-                                      </p:cBhvr>
-                                      <p:to>
-                                        <p:strVal val="visible"/>
-                                      </p:to>
-                                    </p:set>
-                                  </p:childTnLst>
-                                </p:cTn>
-                              </p:par>
-                            </p:childTnLst>
-                          </p:cTn>
-                        </p:par>
-                      </p:childTnLst>
-                    </p:cTn>
-                  </p:par>
-                </p:childTnLst>
-              </p:cTn>
-              <p:prevCondLst>
-                <p:cond evt="onPrev" delay="0">
-                  <p:tgtEl>
-                    <p:sldTgt/>
-                  </p:tgtEl>
-                </p:cond>
-              </p:prevCondLst>
-              <p:nextCondLst>
-                <p:cond evt="onNext" delay="0">
-                  <p:tgtEl>
-                    <p:sldTgt/>
-                  </p:tgtEl>
-                </p:cond>
-              </p:nextCondLst>
-            </p:seq>
-          </p:childTnLst>
-        </p:cTn>
-      </p:par>
-    </p:tnLst>
-  </p:timing>
 </p:sld>
 </file>
 
@@ -40802,6 +40862,455 @@
         <p:cNvPr id="1" name="">
           <a:extLst>
             <a:ext uri="{FF2B5EF4-FFF2-40B4-BE49-F238E27FC236}">
+              <a16:creationId xmlns:a16="http://schemas.microsoft.com/office/drawing/2014/main" id="{061B13E0-3E87-00EB-FAED-C1660C725917}"/>
+            </a:ext>
+          </a:extLst>
+        </p:cNvPr>
+        <p:cNvGrpSpPr/>
+        <p:nvPr/>
+      </p:nvGrpSpPr>
+      <p:grpSpPr>
+        <a:xfrm>
+          <a:off x="0" y="0"/>
+          <a:ext cx="0" cy="0"/>
+          <a:chOff x="0" y="0"/>
+          <a:chExt cx="0" cy="0"/>
+        </a:xfrm>
+      </p:grpSpPr>
+      <p:sp>
+        <p:nvSpPr>
+          <p:cNvPr id="5" name="Date Placeholder 4">
+            <a:extLst>
+              <a:ext uri="{FF2B5EF4-FFF2-40B4-BE49-F238E27FC236}">
+                <a16:creationId xmlns:a16="http://schemas.microsoft.com/office/drawing/2014/main" id="{6177AF59-EA2D-41F4-9542-F2556090BB96}"/>
+              </a:ext>
+            </a:extLst>
+          </p:cNvPr>
+          <p:cNvSpPr>
+            <a:spLocks noGrp="1"/>
+          </p:cNvSpPr>
+          <p:nvPr>
+            <p:ph type="dt" sz="half" idx="10"/>
+          </p:nvPr>
+        </p:nvSpPr>
+        <p:spPr/>
+        <p:txBody>
+          <a:bodyPr/>
+          <a:lstStyle/>
+          <a:p>
+            <a:fld id="{334F72C3-CDF3-44A8-B602-1649B1728485}" type="datetime3">
+              <a:rPr lang="en-US" smtClean="0"/>
+              <a:t>10 July 2026</a:t>
+            </a:fld>
+            <a:endParaRPr lang="en-US"/>
+          </a:p>
+        </p:txBody>
+      </p:sp>
+      <p:sp>
+        <p:nvSpPr>
+          <p:cNvPr id="6" name="Slide Number Placeholder 5">
+            <a:extLst>
+              <a:ext uri="{FF2B5EF4-FFF2-40B4-BE49-F238E27FC236}">
+                <a16:creationId xmlns:a16="http://schemas.microsoft.com/office/drawing/2014/main" id="{F4C119CF-0F77-60E2-B8F0-81835FEAD513}"/>
+              </a:ext>
+            </a:extLst>
+          </p:cNvPr>
+          <p:cNvSpPr>
+            <a:spLocks noGrp="1"/>
+          </p:cNvSpPr>
+          <p:nvPr>
+            <p:ph type="sldNum" sz="quarter" idx="11"/>
+          </p:nvPr>
+        </p:nvSpPr>
+        <p:spPr/>
+        <p:txBody>
+          <a:bodyPr/>
+          <a:lstStyle/>
+          <a:p>
+            <a:fld id="{64E5BE4B-2FBF-4174-9E62-85FAD1CB43A6}" type="slidenum">
+              <a:rPr lang="en-US" smtClean="0"/>
+              <a:pPr/>
+              <a:t>30</a:t>
+            </a:fld>
+            <a:endParaRPr lang="en-US"/>
+          </a:p>
+        </p:txBody>
+      </p:sp>
+      <p:sp>
+        <p:nvSpPr>
+          <p:cNvPr id="11" name="Content Placeholder 10">
+            <a:extLst>
+              <a:ext uri="{FF2B5EF4-FFF2-40B4-BE49-F238E27FC236}">
+                <a16:creationId xmlns:a16="http://schemas.microsoft.com/office/drawing/2014/main" id="{028668B5-9C66-E6D4-D5EA-B52A0AAC5AA4}"/>
+              </a:ext>
+            </a:extLst>
+          </p:cNvPr>
+          <p:cNvSpPr>
+            <a:spLocks noGrp="1"/>
+          </p:cNvSpPr>
+          <p:nvPr>
+            <p:ph sz="half" idx="1"/>
+          </p:nvPr>
+        </p:nvSpPr>
+        <p:spPr>
+          <a:xfrm>
+            <a:off x="411478" y="1200150"/>
+            <a:ext cx="8219566" cy="3429000"/>
+          </a:xfrm>
+        </p:spPr>
+        <p:txBody>
+          <a:bodyPr/>
+          <a:lstStyle/>
+          <a:p>
+            <a:r>
+              <a:rPr lang="en-US" sz="1800" dirty="0"/>
+              <a:t>What datatypes can it accept?</a:t>
+            </a:r>
+          </a:p>
+          <a:p>
+            <a:endParaRPr lang="en-US" sz="1800" dirty="0"/>
+          </a:p>
+          <a:p>
+            <a:endParaRPr lang="en-US" sz="1800" dirty="0"/>
+          </a:p>
+          <a:p>
+            <a:endParaRPr lang="en-US" sz="1800" dirty="0"/>
+          </a:p>
+          <a:p>
+            <a:endParaRPr lang="en-US" sz="1800" dirty="0"/>
+          </a:p>
+          <a:p>
+            <a:endParaRPr lang="en-US" sz="1800" dirty="0"/>
+          </a:p>
+          <a:p>
+            <a:endParaRPr lang="en-US" sz="1800" dirty="0"/>
+          </a:p>
+          <a:p>
+            <a:r>
+              <a:rPr lang="en-US" sz="1800" dirty="0"/>
+              <a:t>What do you notice about the output on the right?</a:t>
+            </a:r>
+          </a:p>
+          <a:p>
+            <a:endParaRPr lang="en-US" sz="1800" dirty="0"/>
+          </a:p>
+          <a:p>
+            <a:endParaRPr lang="en-US" sz="1800" dirty="0"/>
+          </a:p>
+        </p:txBody>
+      </p:sp>
+      <p:sp>
+        <p:nvSpPr>
+          <p:cNvPr id="3" name="Google Shape;319;p55">
+            <a:extLst>
+              <a:ext uri="{FF2B5EF4-FFF2-40B4-BE49-F238E27FC236}">
+                <a16:creationId xmlns:a16="http://schemas.microsoft.com/office/drawing/2014/main" id="{D691970B-10BB-3724-A871-F43E1C6BBA17}"/>
+              </a:ext>
+            </a:extLst>
+          </p:cNvPr>
+          <p:cNvSpPr txBox="1">
+            <a:spLocks/>
+          </p:cNvSpPr>
+          <p:nvPr/>
+        </p:nvSpPr>
+        <p:spPr>
+          <a:xfrm>
+            <a:off x="288816" y="408972"/>
+            <a:ext cx="6173470" cy="685800"/>
+          </a:xfrm>
+          <a:prstGeom prst="rect">
+            <a:avLst/>
+          </a:prstGeom>
+          <a:noFill/>
+          <a:ln>
+            <a:noFill/>
+          </a:ln>
+        </p:spPr>
+        <p:txBody>
+          <a:bodyPr spcFirstLastPara="1" vert="horz" wrap="square" lIns="91425" tIns="45700" rIns="91425" bIns="45700" rtlCol="0" anchor="ctr" anchorCtr="0">
+            <a:normAutofit lnSpcReduction="10000"/>
+          </a:bodyPr>
+          <a:lstStyle>
+            <a:lvl1pPr algn="l" defTabSz="685800" rtl="0" eaLnBrk="1" latinLnBrk="0" hangingPunct="1">
+              <a:lnSpc>
+                <a:spcPct val="90000"/>
+              </a:lnSpc>
+              <a:spcBef>
+                <a:spcPct val="0"/>
+              </a:spcBef>
+              <a:buNone/>
+              <a:defRPr sz="2400" kern="1200" cap="all" baseline="0">
+                <a:solidFill>
+                  <a:schemeClr val="tx1"/>
+                </a:solidFill>
+                <a:latin typeface="+mj-lt"/>
+                <a:ea typeface="+mj-ea"/>
+                <a:cs typeface="+mj-cs"/>
+              </a:defRPr>
+            </a:lvl1pPr>
+          </a:lstStyle>
+          <a:p>
+            <a:pPr>
+              <a:buClrTx/>
+              <a:buFontTx/>
+            </a:pPr>
+            <a:r>
+              <a:rPr lang="en-US" dirty="0"/>
+              <a:t>MORE INFORMATION ABOU THE PRINT FUNCTION</a:t>
+            </a:r>
+          </a:p>
+        </p:txBody>
+      </p:sp>
+      <p:pic>
+        <p:nvPicPr>
+          <p:cNvPr id="4" name="Picture 3">
+            <a:extLst>
+              <a:ext uri="{FF2B5EF4-FFF2-40B4-BE49-F238E27FC236}">
+                <a16:creationId xmlns:a16="http://schemas.microsoft.com/office/drawing/2014/main" id="{A80242B1-EC70-BB1C-21A7-77FF11664436}"/>
+              </a:ext>
+            </a:extLst>
+          </p:cNvPr>
+          <p:cNvPicPr>
+            <a:picLocks noChangeAspect="1"/>
+          </p:cNvPicPr>
+          <p:nvPr/>
+        </p:nvPicPr>
+        <p:blipFill>
+          <a:blip r:embed="rId2"/>
+          <a:stretch>
+            <a:fillRect/>
+          </a:stretch>
+        </p:blipFill>
+        <p:spPr>
+          <a:xfrm>
+            <a:off x="1191396" y="1947775"/>
+            <a:ext cx="2600688" cy="1247949"/>
+          </a:xfrm>
+          <a:prstGeom prst="rect">
+            <a:avLst/>
+          </a:prstGeom>
+        </p:spPr>
+      </p:pic>
+      <p:pic>
+        <p:nvPicPr>
+          <p:cNvPr id="8" name="Picture 7">
+            <a:extLst>
+              <a:ext uri="{FF2B5EF4-FFF2-40B4-BE49-F238E27FC236}">
+                <a16:creationId xmlns:a16="http://schemas.microsoft.com/office/drawing/2014/main" id="{62D308B4-278C-41B1-7565-C6C0C20A65D6}"/>
+              </a:ext>
+            </a:extLst>
+          </p:cNvPr>
+          <p:cNvPicPr>
+            <a:picLocks noChangeAspect="1"/>
+          </p:cNvPicPr>
+          <p:nvPr/>
+        </p:nvPicPr>
+        <p:blipFill>
+          <a:blip r:embed="rId3"/>
+          <a:stretch>
+            <a:fillRect/>
+          </a:stretch>
+        </p:blipFill>
+        <p:spPr>
+          <a:xfrm>
+            <a:off x="5649510" y="1985879"/>
+            <a:ext cx="1124107" cy="1171739"/>
+          </a:xfrm>
+          <a:prstGeom prst="rect">
+            <a:avLst/>
+          </a:prstGeom>
+        </p:spPr>
+      </p:pic>
+    </p:spTree>
+    <p:extLst>
+      <p:ext uri="{BB962C8B-B14F-4D97-AF65-F5344CB8AC3E}">
+        <p14:creationId xmlns:p14="http://schemas.microsoft.com/office/powerpoint/2010/main" val="2564714597"/>
+      </p:ext>
+    </p:extLst>
+  </p:cSld>
+  <p:clrMapOvr>
+    <a:masterClrMapping/>
+  </p:clrMapOvr>
+  <p:timing>
+    <p:tnLst>
+      <p:par>
+        <p:cTn id="1" dur="indefinite" restart="never" nodeType="tmRoot">
+          <p:childTnLst>
+            <p:seq concurrent="1" nextAc="seek">
+              <p:cTn id="2" dur="indefinite" nodeType="mainSeq">
+                <p:childTnLst>
+                  <p:par>
+                    <p:cTn id="3" fill="hold">
+                      <p:stCondLst>
+                        <p:cond delay="indefinite"/>
+                      </p:stCondLst>
+                      <p:childTnLst>
+                        <p:par>
+                          <p:cTn id="4" fill="hold">
+                            <p:stCondLst>
+                              <p:cond delay="0"/>
+                            </p:stCondLst>
+                            <p:childTnLst>
+                              <p:par>
+                                <p:cTn id="5" presetID="1" presetClass="entr" presetSubtype="0" fill="hold" nodeType="clickEffect">
+                                  <p:stCondLst>
+                                    <p:cond delay="0"/>
+                                  </p:stCondLst>
+                                  <p:childTnLst>
+                                    <p:set>
+                                      <p:cBhvr>
+                                        <p:cTn id="6" dur="1" fill="hold">
+                                          <p:stCondLst>
+                                            <p:cond delay="0"/>
+                                          </p:stCondLst>
+                                        </p:cTn>
+                                        <p:tgtEl>
+                                          <p:spTgt spid="4"/>
+                                        </p:tgtEl>
+                                        <p:attrNameLst>
+                                          <p:attrName>style.visibility</p:attrName>
+                                        </p:attrNameLst>
+                                      </p:cBhvr>
+                                      <p:to>
+                                        <p:strVal val="visible"/>
+                                      </p:to>
+                                    </p:set>
+                                  </p:childTnLst>
+                                </p:cTn>
+                              </p:par>
+                            </p:childTnLst>
+                          </p:cTn>
+                        </p:par>
+                      </p:childTnLst>
+                    </p:cTn>
+                  </p:par>
+                  <p:par>
+                    <p:cTn id="7" fill="hold">
+                      <p:stCondLst>
+                        <p:cond delay="indefinite"/>
+                      </p:stCondLst>
+                      <p:childTnLst>
+                        <p:par>
+                          <p:cTn id="8" fill="hold">
+                            <p:stCondLst>
+                              <p:cond delay="0"/>
+                            </p:stCondLst>
+                            <p:childTnLst>
+                              <p:par>
+                                <p:cTn id="9" presetID="1" presetClass="entr" presetSubtype="0" fill="hold" nodeType="clickEffect">
+                                  <p:stCondLst>
+                                    <p:cond delay="0"/>
+                                  </p:stCondLst>
+                                  <p:childTnLst>
+                                    <p:set>
+                                      <p:cBhvr>
+                                        <p:cTn id="10" dur="1" fill="hold">
+                                          <p:stCondLst>
+                                            <p:cond delay="0"/>
+                                          </p:stCondLst>
+                                        </p:cTn>
+                                        <p:tgtEl>
+                                          <p:spTgt spid="8"/>
+                                        </p:tgtEl>
+                                        <p:attrNameLst>
+                                          <p:attrName>style.visibility</p:attrName>
+                                        </p:attrNameLst>
+                                      </p:cBhvr>
+                                      <p:to>
+                                        <p:strVal val="visible"/>
+                                      </p:to>
+                                    </p:set>
+                                  </p:childTnLst>
+                                </p:cTn>
+                              </p:par>
+                            </p:childTnLst>
+                          </p:cTn>
+                        </p:par>
+                      </p:childTnLst>
+                    </p:cTn>
+                  </p:par>
+                  <p:par>
+                    <p:cTn id="11" fill="hold">
+                      <p:stCondLst>
+                        <p:cond delay="indefinite"/>
+                      </p:stCondLst>
+                      <p:childTnLst>
+                        <p:par>
+                          <p:cTn id="12" fill="hold">
+                            <p:stCondLst>
+                              <p:cond delay="0"/>
+                            </p:stCondLst>
+                            <p:childTnLst>
+                              <p:par>
+                                <p:cTn id="13" presetID="1" presetClass="entr" presetSubtype="0" fill="hold" nodeType="clickEffect">
+                                  <p:stCondLst>
+                                    <p:cond delay="0"/>
+                                  </p:stCondLst>
+                                  <p:childTnLst>
+                                    <p:set>
+                                      <p:cBhvr>
+                                        <p:cTn id="14" dur="1" fill="hold">
+                                          <p:stCondLst>
+                                            <p:cond delay="0"/>
+                                          </p:stCondLst>
+                                        </p:cTn>
+                                        <p:tgtEl>
+                                          <p:spTgt spid="11">
+                                            <p:txEl>
+                                              <p:pRg st="7" end="7"/>
+                                            </p:txEl>
+                                          </p:spTgt>
+                                        </p:tgtEl>
+                                        <p:attrNameLst>
+                                          <p:attrName>style.visibility</p:attrName>
+                                        </p:attrNameLst>
+                                      </p:cBhvr>
+                                      <p:to>
+                                        <p:strVal val="visible"/>
+                                      </p:to>
+                                    </p:set>
+                                  </p:childTnLst>
+                                </p:cTn>
+                              </p:par>
+                            </p:childTnLst>
+                          </p:cTn>
+                        </p:par>
+                      </p:childTnLst>
+                    </p:cTn>
+                  </p:par>
+                </p:childTnLst>
+              </p:cTn>
+              <p:prevCondLst>
+                <p:cond evt="onPrev" delay="0">
+                  <p:tgtEl>
+                    <p:sldTgt/>
+                  </p:tgtEl>
+                </p:cond>
+              </p:prevCondLst>
+              <p:nextCondLst>
+                <p:cond evt="onNext" delay="0">
+                  <p:tgtEl>
+                    <p:sldTgt/>
+                  </p:tgtEl>
+                </p:cond>
+              </p:nextCondLst>
+            </p:seq>
+          </p:childTnLst>
+        </p:cTn>
+      </p:par>
+    </p:tnLst>
+  </p:timing>
+</p:sld>
+</file>
+
+<file path=ppt/slides/slide31.xml><?xml version="1.0" encoding="utf-8"?>
+<p:sld xmlns:a="http://schemas.openxmlformats.org/drawingml/2006/main" xmlns:r="http://schemas.openxmlformats.org/officeDocument/2006/relationships" xmlns:p="http://schemas.openxmlformats.org/presentationml/2006/main">
+  <p:cSld>
+    <p:spTree>
+      <p:nvGrpSpPr>
+        <p:cNvPr id="1" name="">
+          <a:extLst>
+            <a:ext uri="{FF2B5EF4-FFF2-40B4-BE49-F238E27FC236}">
               <a16:creationId xmlns:a16="http://schemas.microsoft.com/office/drawing/2014/main" id="{01B00F46-32C4-D97A-2CDA-CB446227CEA0}"/>
             </a:ext>
           </a:extLst>
@@ -40840,7 +41349,7 @@
           <a:p>
             <a:fld id="{334F72C3-CDF3-44A8-B602-1649B1728485}" type="datetime3">
               <a:rPr lang="en-US" smtClean="0"/>
-              <a:t>9 July 2026</a:t>
+              <a:t>10 July 2026</a:t>
             </a:fld>
             <a:endParaRPr lang="en-US"/>
           </a:p>
@@ -40870,7 +41379,7 @@
             <a:fld id="{64E5BE4B-2FBF-4174-9E62-85FAD1CB43A6}" type="slidenum">
               <a:rPr lang="en-US" smtClean="0"/>
               <a:pPr/>
-              <a:t>30</a:t>
+              <a:t>31</a:t>
             </a:fld>
             <a:endParaRPr lang="en-US"/>
           </a:p>
@@ -41295,7 +41804,7 @@
 </p:sld>
 </file>
 
-<file path=ppt/slides/slide31.xml><?xml version="1.0" encoding="utf-8"?>
+<file path=ppt/slides/slide32.xml><?xml version="1.0" encoding="utf-8"?>
 <p:sld xmlns:a="http://schemas.openxmlformats.org/drawingml/2006/main" xmlns:r="http://schemas.openxmlformats.org/officeDocument/2006/relationships" xmlns:p="http://schemas.openxmlformats.org/presentationml/2006/main">
   <p:cSld>
     <p:spTree>
@@ -41341,7 +41850,7 @@
           <a:p>
             <a:fld id="{334F72C3-CDF3-44A8-B602-1649B1728485}" type="datetime3">
               <a:rPr lang="en-US" smtClean="0"/>
-              <a:t>9 July 2026</a:t>
+              <a:t>10 July 2026</a:t>
             </a:fld>
             <a:endParaRPr lang="en-US"/>
           </a:p>
@@ -41371,7 +41880,7 @@
             <a:fld id="{64E5BE4B-2FBF-4174-9E62-85FAD1CB43A6}" type="slidenum">
               <a:rPr lang="en-US" smtClean="0"/>
               <a:pPr/>
-              <a:t>31</a:t>
+              <a:t>32</a:t>
             </a:fld>
             <a:endParaRPr lang="en-US"/>
           </a:p>
@@ -41758,7 +42267,7 @@
 </p:sld>
 </file>
 
-<file path=ppt/slides/slide32.xml><?xml version="1.0" encoding="utf-8"?>
+<file path=ppt/slides/slide33.xml><?xml version="1.0" encoding="utf-8"?>
 <p:sld xmlns:a="http://schemas.openxmlformats.org/drawingml/2006/main" xmlns:r="http://schemas.openxmlformats.org/officeDocument/2006/relationships" xmlns:p="http://schemas.openxmlformats.org/presentationml/2006/main">
   <p:cSld>
     <p:spTree>
@@ -41804,7 +42313,7 @@
           <a:p>
             <a:fld id="{334F72C3-CDF3-44A8-B602-1649B1728485}" type="datetime3">
               <a:rPr lang="en-US" smtClean="0"/>
-              <a:t>9 July 2026</a:t>
+              <a:t>10 July 2026</a:t>
             </a:fld>
             <a:endParaRPr lang="en-US"/>
           </a:p>
@@ -41834,7 +42343,7 @@
             <a:fld id="{64E5BE4B-2FBF-4174-9E62-85FAD1CB43A6}" type="slidenum">
               <a:rPr lang="en-US" smtClean="0"/>
               <a:pPr/>
-              <a:t>32</a:t>
+              <a:t>33</a:t>
             </a:fld>
             <a:endParaRPr lang="en-US"/>
           </a:p>
@@ -42087,7 +42596,7 @@
 </p:sld>
 </file>
 
-<file path=ppt/slides/slide33.xml><?xml version="1.0" encoding="utf-8"?>
+<file path=ppt/slides/slide34.xml><?xml version="1.0" encoding="utf-8"?>
 <p:sld xmlns:a="http://schemas.openxmlformats.org/drawingml/2006/main" xmlns:r="http://schemas.openxmlformats.org/officeDocument/2006/relationships" xmlns:p="http://schemas.openxmlformats.org/presentationml/2006/main">
   <p:cSld>
     <p:spTree>
@@ -42133,7 +42642,7 @@
           <a:p>
             <a:fld id="{334F72C3-CDF3-44A8-B602-1649B1728485}" type="datetime3">
               <a:rPr lang="en-US" smtClean="0"/>
-              <a:t>9 July 2026</a:t>
+              <a:t>10 July 2026</a:t>
             </a:fld>
             <a:endParaRPr lang="en-US"/>
           </a:p>
@@ -42163,7 +42672,7 @@
             <a:fld id="{64E5BE4B-2FBF-4174-9E62-85FAD1CB43A6}" type="slidenum">
               <a:rPr lang="en-US" smtClean="0"/>
               <a:pPr/>
-              <a:t>33</a:t>
+              <a:t>34</a:t>
             </a:fld>
             <a:endParaRPr lang="en-US"/>
           </a:p>
@@ -42539,7 +43048,7 @@
 </p:sld>
 </file>
 
-<file path=ppt/slides/slide34.xml><?xml version="1.0" encoding="utf-8"?>
+<file path=ppt/slides/slide35.xml><?xml version="1.0" encoding="utf-8"?>
 <p:sld xmlns:a="http://schemas.openxmlformats.org/drawingml/2006/main" xmlns:r="http://schemas.openxmlformats.org/officeDocument/2006/relationships" xmlns:p="http://schemas.openxmlformats.org/presentationml/2006/main">
   <p:cSld>
     <p:spTree>
@@ -42714,7 +43223,7 @@
 </p:sld>
 </file>
 
-<file path=ppt/slides/slide35.xml><?xml version="1.0" encoding="utf-8"?>
+<file path=ppt/slides/slide36.xml><?xml version="1.0" encoding="utf-8"?>
 <p:sld xmlns:a="http://schemas.openxmlformats.org/drawingml/2006/main" xmlns:r="http://schemas.openxmlformats.org/officeDocument/2006/relationships" xmlns:p="http://schemas.openxmlformats.org/presentationml/2006/main">
   <p:cSld>
     <p:spTree>
@@ -43333,7 +43842,7 @@
 </p:sld>
 </file>
 
-<file path=ppt/slides/slide36.xml><?xml version="1.0" encoding="utf-8"?>
+<file path=ppt/slides/slide37.xml><?xml version="1.0" encoding="utf-8"?>
 <p:sld xmlns:a="http://schemas.openxmlformats.org/drawingml/2006/main" xmlns:r="http://schemas.openxmlformats.org/officeDocument/2006/relationships" xmlns:p="http://schemas.openxmlformats.org/presentationml/2006/main">
   <p:cSld>
     <p:spTree>
@@ -43408,7 +43917,7 @@
           <a:p>
             <a:fld id="{AD622D1A-DF83-41A8-85FF-04D90BF831D3}" type="datetime3">
               <a:rPr lang="en-US" smtClean="0"/>
-              <a:t>9 July 2026</a:t>
+              <a:t>10 July 2026</a:t>
             </a:fld>
             <a:endParaRPr lang="en-US"/>
           </a:p>
@@ -43438,7 +43947,7 @@
             <a:fld id="{64E5BE4B-2FBF-4174-9E62-85FAD1CB43A6}" type="slidenum">
               <a:rPr lang="en-US" smtClean="0"/>
               <a:pPr/>
-              <a:t>36</a:t>
+              <a:t>37</a:t>
             </a:fld>
             <a:endParaRPr lang="en-US"/>
           </a:p>
@@ -43617,6 +44126,124 @@
   <p:cSld>
     <p:spTree>
       <p:nvGrpSpPr>
+        <p:cNvPr id="1" name="">
+          <a:extLst>
+            <a:ext uri="{FF2B5EF4-FFF2-40B4-BE49-F238E27FC236}">
+              <a16:creationId xmlns:a16="http://schemas.microsoft.com/office/drawing/2014/main" id="{1723498B-3908-AA1C-429B-3DD42237C9F5}"/>
+            </a:ext>
+          </a:extLst>
+        </p:cNvPr>
+        <p:cNvGrpSpPr/>
+        <p:nvPr/>
+      </p:nvGrpSpPr>
+      <p:grpSpPr>
+        <a:xfrm>
+          <a:off x="0" y="0"/>
+          <a:ext cx="0" cy="0"/>
+          <a:chOff x="0" y="0"/>
+          <a:chExt cx="0" cy="0"/>
+        </a:xfrm>
+      </p:grpSpPr>
+      <p:sp>
+        <p:nvSpPr>
+          <p:cNvPr id="2" name="Title 1">
+            <a:extLst>
+              <a:ext uri="{FF2B5EF4-FFF2-40B4-BE49-F238E27FC236}">
+                <a16:creationId xmlns:a16="http://schemas.microsoft.com/office/drawing/2014/main" id="{08629C2F-BEB8-93F7-6CAE-4B84A831BEB8}"/>
+              </a:ext>
+            </a:extLst>
+          </p:cNvPr>
+          <p:cNvSpPr>
+            <a:spLocks noGrp="1"/>
+          </p:cNvSpPr>
+          <p:nvPr>
+            <p:ph type="title"/>
+          </p:nvPr>
+        </p:nvSpPr>
+        <p:spPr/>
+        <p:txBody>
+          <a:bodyPr/>
+          <a:lstStyle/>
+          <a:p>
+            <a:br>
+              <a:rPr lang="en-US" dirty="0"/>
+            </a:br>
+            <a:r>
+              <a:rPr lang="en-US" dirty="0"/>
+              <a:t>Before we dive in…</a:t>
+            </a:r>
+          </a:p>
+        </p:txBody>
+      </p:sp>
+      <p:sp>
+        <p:nvSpPr>
+          <p:cNvPr id="4" name="Content Placeholder 3">
+            <a:extLst>
+              <a:ext uri="{FF2B5EF4-FFF2-40B4-BE49-F238E27FC236}">
+                <a16:creationId xmlns:a16="http://schemas.microsoft.com/office/drawing/2014/main" id="{DF586E60-3DEB-D270-B927-C0DA20680FE7}"/>
+              </a:ext>
+            </a:extLst>
+          </p:cNvPr>
+          <p:cNvSpPr>
+            <a:spLocks noGrp="1"/>
+          </p:cNvSpPr>
+          <p:nvPr>
+            <p:ph idx="1"/>
+          </p:nvPr>
+        </p:nvSpPr>
+        <p:spPr/>
+        <p:txBody>
+          <a:bodyPr/>
+          <a:lstStyle/>
+          <a:p>
+            <a:r>
+              <a:rPr lang="en-US" dirty="0"/>
+              <a:t>Pull changes from the summer-courses remote repo to your version of the remote repo</a:t>
+            </a:r>
+          </a:p>
+          <a:p>
+            <a:endParaRPr lang="en-US" dirty="0"/>
+          </a:p>
+          <a:p>
+            <a:r>
+              <a:rPr lang="en-US" dirty="0"/>
+              <a:t>Pull those changes locally</a:t>
+            </a:r>
+          </a:p>
+          <a:p>
+            <a:endParaRPr lang="en-US" dirty="0"/>
+          </a:p>
+          <a:p>
+            <a:r>
+              <a:rPr lang="en-US" dirty="0"/>
+              <a:t>Create a notes file in the lesson one folder… </a:t>
+            </a:r>
+            <a:r>
+              <a:rPr lang="en-US"/>
+              <a:t>I recommend ‘lesson1_notes.py’</a:t>
+            </a:r>
+            <a:endParaRPr lang="en-US" dirty="0"/>
+          </a:p>
+        </p:txBody>
+      </p:sp>
+    </p:spTree>
+    <p:extLst>
+      <p:ext uri="{BB962C8B-B14F-4D97-AF65-F5344CB8AC3E}">
+        <p14:creationId xmlns:p14="http://schemas.microsoft.com/office/powerpoint/2010/main" val="965181585"/>
+      </p:ext>
+    </p:extLst>
+  </p:cSld>
+  <p:clrMapOvr>
+    <a:masterClrMapping/>
+  </p:clrMapOvr>
+</p:sld>
+</file>
+
+<file path=ppt/slides/slide6.xml><?xml version="1.0" encoding="utf-8"?>
+<p:sld xmlns:a="http://schemas.openxmlformats.org/drawingml/2006/main" xmlns:r="http://schemas.openxmlformats.org/officeDocument/2006/relationships" xmlns:p="http://schemas.openxmlformats.org/presentationml/2006/main">
+  <p:cSld>
+    <p:spTree>
+      <p:nvGrpSpPr>
         <p:cNvPr id="1" name="Shape 259">
           <a:extLst>
             <a:ext uri="{FF2B5EF4-FFF2-40B4-BE49-F238E27FC236}">
@@ -43802,7 +44429,7 @@
 </p:sld>
 </file>
 
-<file path=ppt/slides/slide6.xml><?xml version="1.0" encoding="utf-8"?>
+<file path=ppt/slides/slide7.xml><?xml version="1.0" encoding="utf-8"?>
 <p:sld xmlns:a="http://schemas.openxmlformats.org/drawingml/2006/main" xmlns:r="http://schemas.openxmlformats.org/officeDocument/2006/relationships" xmlns:p="http://schemas.openxmlformats.org/presentationml/2006/main">
   <p:cSld>
     <p:spTree>
@@ -43949,7 +44576,7 @@
 </p:sld>
 </file>
 
-<file path=ppt/slides/slide7.xml><?xml version="1.0" encoding="utf-8"?>
+<file path=ppt/slides/slide8.xml><?xml version="1.0" encoding="utf-8"?>
 <p:sld xmlns:a="http://schemas.openxmlformats.org/drawingml/2006/main" xmlns:r="http://schemas.openxmlformats.org/officeDocument/2006/relationships" xmlns:p="http://schemas.openxmlformats.org/presentationml/2006/main">
   <p:cSld>
     <p:spTree>
@@ -44159,7 +44786,7 @@
           <a:p>
             <a:fld id="{AD622D1A-DF83-41A8-85FF-04D90BF831D3}" type="datetime3">
               <a:rPr lang="en-US" smtClean="0"/>
-              <a:t>9 July 2026</a:t>
+              <a:t>10 July 2026</a:t>
             </a:fld>
             <a:endParaRPr lang="en-US"/>
           </a:p>
@@ -44189,7 +44816,7 @@
             <a:fld id="{64E5BE4B-2FBF-4174-9E62-85FAD1CB43A6}" type="slidenum">
               <a:rPr lang="en-US" smtClean="0"/>
               <a:pPr/>
-              <a:t>7</a:t>
+              <a:t>8</a:t>
             </a:fld>
             <a:endParaRPr lang="en-US"/>
           </a:p>
@@ -44208,7 +44835,7 @@
 </p:sld>
 </file>
 
-<file path=ppt/slides/slide8.xml><?xml version="1.0" encoding="utf-8"?>
+<file path=ppt/slides/slide9.xml><?xml version="1.0" encoding="utf-8"?>
 <p:sld xmlns:a="http://schemas.openxmlformats.org/drawingml/2006/main" xmlns:r="http://schemas.openxmlformats.org/officeDocument/2006/relationships" xmlns:p="http://schemas.openxmlformats.org/presentationml/2006/main">
   <p:cSld>
     <p:spTree>
@@ -45013,401 +45640,6 @@
 </p:sld>
 </file>
 
-<file path=ppt/slides/slide9.xml><?xml version="1.0" encoding="utf-8"?>
-<p:sld xmlns:a="http://schemas.openxmlformats.org/drawingml/2006/main" xmlns:r="http://schemas.openxmlformats.org/officeDocument/2006/relationships" xmlns:p="http://schemas.openxmlformats.org/presentationml/2006/main">
-  <p:cSld>
-    <p:spTree>
-      <p:nvGrpSpPr>
-        <p:cNvPr id="1" name=""/>
-        <p:cNvGrpSpPr/>
-        <p:nvPr/>
-      </p:nvGrpSpPr>
-      <p:grpSpPr>
-        <a:xfrm>
-          <a:off x="0" y="0"/>
-          <a:ext cx="0" cy="0"/>
-          <a:chOff x="0" y="0"/>
-          <a:chExt cx="0" cy="0"/>
-        </a:xfrm>
-      </p:grpSpPr>
-      <p:sp>
-        <p:nvSpPr>
-          <p:cNvPr id="2" name="Title 1">
-            <a:extLst>
-              <a:ext uri="{FF2B5EF4-FFF2-40B4-BE49-F238E27FC236}">
-                <a16:creationId xmlns:a16="http://schemas.microsoft.com/office/drawing/2014/main" id="{C2A42DED-686C-354A-03AA-8C3105239CF9}"/>
-              </a:ext>
-            </a:extLst>
-          </p:cNvPr>
-          <p:cNvSpPr>
-            <a:spLocks noGrp="1"/>
-          </p:cNvSpPr>
-          <p:nvPr>
-            <p:ph type="title"/>
-          </p:nvPr>
-        </p:nvSpPr>
-        <p:spPr/>
-        <p:txBody>
-          <a:bodyPr/>
-          <a:lstStyle/>
-          <a:p>
-            <a:r>
-              <a:rPr lang="en-US" dirty="0"/>
-              <a:t>Spot the Difference</a:t>
-            </a:r>
-          </a:p>
-        </p:txBody>
-      </p:sp>
-      <p:sp>
-        <p:nvSpPr>
-          <p:cNvPr id="3" name="Content Placeholder 2">
-            <a:extLst>
-              <a:ext uri="{FF2B5EF4-FFF2-40B4-BE49-F238E27FC236}">
-                <a16:creationId xmlns:a16="http://schemas.microsoft.com/office/drawing/2014/main" id="{C03A03FA-440C-E5A0-88B6-F6D53B839E7C}"/>
-              </a:ext>
-            </a:extLst>
-          </p:cNvPr>
-          <p:cNvSpPr>
-            <a:spLocks noGrp="1"/>
-          </p:cNvSpPr>
-          <p:nvPr>
-            <p:ph sz="half" idx="1"/>
-          </p:nvPr>
-        </p:nvSpPr>
-        <p:spPr/>
-        <p:txBody>
-          <a:bodyPr/>
-          <a:lstStyle/>
-          <a:p>
-            <a:endParaRPr lang="en-US" dirty="0"/>
-          </a:p>
-          <a:p>
-            <a:endParaRPr lang="en-US" dirty="0"/>
-          </a:p>
-          <a:p>
-            <a:endParaRPr lang="en-US" dirty="0"/>
-          </a:p>
-          <a:p>
-            <a:r>
-              <a:rPr lang="en-US" dirty="0"/>
-              <a:t>01100011011011110110111101101100</a:t>
-            </a:r>
-          </a:p>
-          <a:p>
-            <a:r>
-              <a:rPr lang="en-US" dirty="0"/>
-              <a:t>01100011011011110110111101101100</a:t>
-            </a:r>
-          </a:p>
-          <a:p>
-            <a:r>
-              <a:rPr lang="en-US" dirty="0"/>
-              <a:t>01100011011011110110111101101100</a:t>
-            </a:r>
-          </a:p>
-        </p:txBody>
-      </p:sp>
-      <p:sp>
-        <p:nvSpPr>
-          <p:cNvPr id="4" name="Content Placeholder 3">
-            <a:extLst>
-              <a:ext uri="{FF2B5EF4-FFF2-40B4-BE49-F238E27FC236}">
-                <a16:creationId xmlns:a16="http://schemas.microsoft.com/office/drawing/2014/main" id="{CC29AC81-FB1F-9F08-D768-CB1A89B82987}"/>
-              </a:ext>
-            </a:extLst>
-          </p:cNvPr>
-          <p:cNvSpPr>
-            <a:spLocks noGrp="1"/>
-          </p:cNvSpPr>
-          <p:nvPr>
-            <p:ph sz="half" idx="2"/>
-          </p:nvPr>
-        </p:nvSpPr>
-        <p:spPr/>
-        <p:txBody>
-          <a:bodyPr/>
-          <a:lstStyle/>
-          <a:p>
-            <a:endParaRPr lang="en-US" dirty="0"/>
-          </a:p>
-          <a:p>
-            <a:endParaRPr lang="en-US" dirty="0"/>
-          </a:p>
-          <a:p>
-            <a:endParaRPr lang="en-US" dirty="0"/>
-          </a:p>
-          <a:p>
-            <a:r>
-              <a:rPr lang="en-US" dirty="0"/>
-              <a:t>1,668,247,404 (int)</a:t>
-            </a:r>
-          </a:p>
-          <a:p>
-            <a:r>
-              <a:rPr lang="en-US" dirty="0"/>
-              <a:t>4.4168006258522776e+21 (float)</a:t>
-            </a:r>
-          </a:p>
-          <a:p>
-            <a:r>
-              <a:rPr lang="en-US" dirty="0"/>
-              <a:t>"cool" (string)</a:t>
-            </a:r>
-          </a:p>
-        </p:txBody>
-      </p:sp>
-      <p:sp>
-        <p:nvSpPr>
-          <p:cNvPr id="5" name="Date Placeholder 4">
-            <a:extLst>
-              <a:ext uri="{FF2B5EF4-FFF2-40B4-BE49-F238E27FC236}">
-                <a16:creationId xmlns:a16="http://schemas.microsoft.com/office/drawing/2014/main" id="{D71B38C4-45F3-1654-A84A-E5E00E36AC46}"/>
-              </a:ext>
-            </a:extLst>
-          </p:cNvPr>
-          <p:cNvSpPr>
-            <a:spLocks noGrp="1"/>
-          </p:cNvSpPr>
-          <p:nvPr>
-            <p:ph type="dt" sz="half" idx="10"/>
-          </p:nvPr>
-        </p:nvSpPr>
-        <p:spPr/>
-        <p:txBody>
-          <a:bodyPr/>
-          <a:lstStyle/>
-          <a:p>
-            <a:fld id="{334F72C3-CDF3-44A8-B602-1649B1728485}" type="datetime3">
-              <a:rPr lang="en-US" smtClean="0"/>
-              <a:t>9 July 2026</a:t>
-            </a:fld>
-            <a:endParaRPr lang="en-US"/>
-          </a:p>
-        </p:txBody>
-      </p:sp>
-      <p:sp>
-        <p:nvSpPr>
-          <p:cNvPr id="6" name="Slide Number Placeholder 5">
-            <a:extLst>
-              <a:ext uri="{FF2B5EF4-FFF2-40B4-BE49-F238E27FC236}">
-                <a16:creationId xmlns:a16="http://schemas.microsoft.com/office/drawing/2014/main" id="{6A8CE803-317A-C6AF-DB96-475300B4CBF7}"/>
-              </a:ext>
-            </a:extLst>
-          </p:cNvPr>
-          <p:cNvSpPr>
-            <a:spLocks noGrp="1"/>
-          </p:cNvSpPr>
-          <p:nvPr>
-            <p:ph type="sldNum" sz="quarter" idx="11"/>
-          </p:nvPr>
-        </p:nvSpPr>
-        <p:spPr/>
-        <p:txBody>
-          <a:bodyPr/>
-          <a:lstStyle/>
-          <a:p>
-            <a:fld id="{64E5BE4B-2FBF-4174-9E62-85FAD1CB43A6}" type="slidenum">
-              <a:rPr lang="en-US" smtClean="0"/>
-              <a:pPr/>
-              <a:t>9</a:t>
-            </a:fld>
-            <a:endParaRPr lang="en-US"/>
-          </a:p>
-        </p:txBody>
-      </p:sp>
-    </p:spTree>
-    <p:extLst>
-      <p:ext uri="{BB962C8B-B14F-4D97-AF65-F5344CB8AC3E}">
-        <p14:creationId xmlns:p14="http://schemas.microsoft.com/office/powerpoint/2010/main" val="3848003108"/>
-      </p:ext>
-    </p:extLst>
-  </p:cSld>
-  <p:clrMapOvr>
-    <a:masterClrMapping/>
-  </p:clrMapOvr>
-  <p:timing>
-    <p:tnLst>
-      <p:par>
-        <p:cTn id="1" dur="indefinite" restart="never" nodeType="tmRoot">
-          <p:childTnLst>
-            <p:seq concurrent="1" nextAc="seek">
-              <p:cTn id="2" dur="indefinite" nodeType="mainSeq">
-                <p:childTnLst>
-                  <p:par>
-                    <p:cTn id="3" fill="hold">
-                      <p:stCondLst>
-                        <p:cond delay="indefinite"/>
-                      </p:stCondLst>
-                      <p:childTnLst>
-                        <p:par>
-                          <p:cTn id="4" fill="hold">
-                            <p:stCondLst>
-                              <p:cond delay="0"/>
-                            </p:stCondLst>
-                            <p:childTnLst>
-                              <p:par>
-                                <p:cTn id="5" presetID="1" presetClass="entr" presetSubtype="0" fill="hold" grpId="0" nodeType="clickEffect">
-                                  <p:stCondLst>
-                                    <p:cond delay="0"/>
-                                  </p:stCondLst>
-                                  <p:childTnLst>
-                                    <p:set>
-                                      <p:cBhvr>
-                                        <p:cTn id="6" dur="1" fill="hold">
-                                          <p:stCondLst>
-                                            <p:cond delay="0"/>
-                                          </p:stCondLst>
-                                        </p:cTn>
-                                        <p:tgtEl>
-                                          <p:spTgt spid="4">
-                                            <p:txEl>
-                                              <p:pRg st="3" end="3"/>
-                                            </p:txEl>
-                                          </p:spTgt>
-                                        </p:tgtEl>
-                                        <p:attrNameLst>
-                                          <p:attrName>style.visibility</p:attrName>
-                                        </p:attrNameLst>
-                                      </p:cBhvr>
-                                      <p:to>
-                                        <p:strVal val="visible"/>
-                                      </p:to>
-                                    </p:set>
-                                  </p:childTnLst>
-                                </p:cTn>
-                              </p:par>
-                            </p:childTnLst>
-                          </p:cTn>
-                        </p:par>
-                      </p:childTnLst>
-                    </p:cTn>
-                  </p:par>
-                  <p:par>
-                    <p:cTn id="7" fill="hold">
-                      <p:stCondLst>
-                        <p:cond delay="indefinite"/>
-                      </p:stCondLst>
-                      <p:childTnLst>
-                        <p:par>
-                          <p:cTn id="8" fill="hold">
-                            <p:stCondLst>
-                              <p:cond delay="0"/>
-                            </p:stCondLst>
-                            <p:childTnLst>
-                              <p:par>
-                                <p:cTn id="9" presetID="1" presetClass="entr" presetSubtype="0" fill="hold" grpId="0" nodeType="clickEffect">
-                                  <p:stCondLst>
-                                    <p:cond delay="0"/>
-                                  </p:stCondLst>
-                                  <p:childTnLst>
-                                    <p:set>
-                                      <p:cBhvr>
-                                        <p:cTn id="10" dur="1" fill="hold">
-                                          <p:stCondLst>
-                                            <p:cond delay="0"/>
-                                          </p:stCondLst>
-                                        </p:cTn>
-                                        <p:tgtEl>
-                                          <p:spTgt spid="4">
-                                            <p:txEl>
-                                              <p:pRg st="4" end="4"/>
-                                            </p:txEl>
-                                          </p:spTgt>
-                                        </p:tgtEl>
-                                        <p:attrNameLst>
-                                          <p:attrName>style.visibility</p:attrName>
-                                        </p:attrNameLst>
-                                      </p:cBhvr>
-                                      <p:to>
-                                        <p:strVal val="visible"/>
-                                      </p:to>
-                                    </p:set>
-                                  </p:childTnLst>
-                                </p:cTn>
-                              </p:par>
-                            </p:childTnLst>
-                          </p:cTn>
-                        </p:par>
-                      </p:childTnLst>
-                    </p:cTn>
-                  </p:par>
-                  <p:par>
-                    <p:cTn id="11" fill="hold">
-                      <p:stCondLst>
-                        <p:cond delay="indefinite"/>
-                      </p:stCondLst>
-                      <p:childTnLst>
-                        <p:par>
-                          <p:cTn id="12" fill="hold">
-                            <p:stCondLst>
-                              <p:cond delay="0"/>
-                            </p:stCondLst>
-                            <p:childTnLst>
-                              <p:par>
-                                <p:cTn id="13" presetID="1" presetClass="entr" presetSubtype="0" fill="hold" grpId="0" nodeType="clickEffect">
-                                  <p:stCondLst>
-                                    <p:cond delay="0"/>
-                                  </p:stCondLst>
-                                  <p:childTnLst>
-                                    <p:set>
-                                      <p:cBhvr>
-                                        <p:cTn id="14" dur="1" fill="hold">
-                                          <p:stCondLst>
-                                            <p:cond delay="0"/>
-                                          </p:stCondLst>
-                                        </p:cTn>
-                                        <p:tgtEl>
-                                          <p:spTgt spid="4">
-                                            <p:txEl>
-                                              <p:pRg st="5" end="5"/>
-                                            </p:txEl>
-                                          </p:spTgt>
-                                        </p:tgtEl>
-                                        <p:attrNameLst>
-                                          <p:attrName>style.visibility</p:attrName>
-                                        </p:attrNameLst>
-                                      </p:cBhvr>
-                                      <p:to>
-                                        <p:strVal val="visible"/>
-                                      </p:to>
-                                    </p:set>
-                                  </p:childTnLst>
-                                </p:cTn>
-                              </p:par>
-                            </p:childTnLst>
-                          </p:cTn>
-                        </p:par>
-                      </p:childTnLst>
-                    </p:cTn>
-                  </p:par>
-                </p:childTnLst>
-              </p:cTn>
-              <p:prevCondLst>
-                <p:cond evt="onPrev" delay="0">
-                  <p:tgtEl>
-                    <p:sldTgt/>
-                  </p:tgtEl>
-                </p:cond>
-              </p:prevCondLst>
-              <p:nextCondLst>
-                <p:cond evt="onNext" delay="0">
-                  <p:tgtEl>
-                    <p:sldTgt/>
-                  </p:tgtEl>
-                </p:cond>
-              </p:nextCondLst>
-            </p:seq>
-          </p:childTnLst>
-        </p:cTn>
-      </p:par>
-    </p:tnLst>
-    <p:bldLst>
-      <p:bldP spid="4" grpId="0" build="p"/>
-    </p:bldLst>
-  </p:timing>
-</p:sld>
-</file>
-
 <file path=ppt/theme/theme1.xml><?xml version="1.0" encoding="utf-8"?>
 <a:theme xmlns:a="http://schemas.openxmlformats.org/drawingml/2006/main" name="US Army 2023 AFC DEVCOM Logo">
   <a:themeElements>

</xml_diff>